<commit_message>
refactor: remove redundant radar in scenario voting phase, enlarge comic image on left, move text to right
</commit_message>
<xml_diff>
--- a/誰是文化王_備案簡報_Who_Is_Culture_King.pptx
+++ b/誰是文化王_備案簡報_Who_Is_Culture_King.pptx
@@ -5853,7 +5853,7 @@
         <p:spPr>
           <a:xfrm>
             <a:off x="676656" y="1179576"/>
-            <a:ext cx="4453128" cy="4453128"/>
+            <a:ext cx="5138928" cy="5138928"/>
           </a:xfrm>
           <a:prstGeom prst="roundRect">
             <a:avLst/>
@@ -5906,7 +5906,7 @@
         <p:spPr>
           <a:xfrm>
             <a:off x="731520" y="1234440"/>
-            <a:ext cx="4343400" cy="4343400"/>
+            <a:ext cx="5029200" cy="5029200"/>
           </a:xfrm>
           <a:prstGeom prst="rect">
             <a:avLst/>
@@ -5921,8 +5921,8 @@
         </p:nvSpPr>
         <p:spPr>
           <a:xfrm>
-            <a:off x="5303520" y="1234440"/>
-            <a:ext cx="6156655" cy="3429000"/>
+            <a:off x="5989320" y="1234440"/>
+            <a:ext cx="5468112" cy="3886200"/>
           </a:xfrm>
           <a:prstGeom prst="roundRect">
             <a:avLst/>
@@ -5951,7 +5951,7 @@
           </a:fontRef>
         </p:style>
         <p:txBody>
-          <a:bodyPr rtlCol="0" anchor="ctr" wrap="square" lIns="256032" rIns="256032" tIns="182880"/>
+          <a:bodyPr rtlCol="0" anchor="ctr" wrap="square" lIns="256032" rIns="256032" tIns="201168"/>
           <a:lstStyle/>
           <a:p>
             <a:pPr algn="ctr">
@@ -6095,8 +6095,8 @@
         </p:nvSpPr>
         <p:spPr>
           <a:xfrm>
-            <a:off x="5303520" y="4800600"/>
-            <a:ext cx="6156655" cy="868680"/>
+            <a:off x="5989320" y="5257800"/>
+            <a:ext cx="5468112" cy="1005840"/>
           </a:xfrm>
           <a:prstGeom prst="roundRect">
             <a:avLst/>
@@ -10365,7 +10365,7 @@
         <p:spPr>
           <a:xfrm>
             <a:off x="676656" y="1179576"/>
-            <a:ext cx="4453128" cy="4453128"/>
+            <a:ext cx="5138928" cy="5138928"/>
           </a:xfrm>
           <a:prstGeom prst="roundRect">
             <a:avLst/>
@@ -10418,7 +10418,7 @@
         <p:spPr>
           <a:xfrm>
             <a:off x="731520" y="1234440"/>
-            <a:ext cx="4343400" cy="4343400"/>
+            <a:ext cx="5029200" cy="5029200"/>
           </a:xfrm>
           <a:prstGeom prst="rect">
             <a:avLst/>
@@ -10433,8 +10433,8 @@
         </p:nvSpPr>
         <p:spPr>
           <a:xfrm>
-            <a:off x="5303520" y="1234440"/>
-            <a:ext cx="6156655" cy="3429000"/>
+            <a:off x="5989320" y="1234440"/>
+            <a:ext cx="5468112" cy="3886200"/>
           </a:xfrm>
           <a:prstGeom prst="roundRect">
             <a:avLst/>
@@ -10463,7 +10463,7 @@
           </a:fontRef>
         </p:style>
         <p:txBody>
-          <a:bodyPr rtlCol="0" anchor="ctr" wrap="square" lIns="256032" rIns="256032" tIns="182880"/>
+          <a:bodyPr rtlCol="0" anchor="ctr" wrap="square" lIns="256032" rIns="256032" tIns="201168"/>
           <a:lstStyle/>
           <a:p>
             <a:pPr algn="ctr">
@@ -10607,8 +10607,8 @@
         </p:nvSpPr>
         <p:spPr>
           <a:xfrm>
-            <a:off x="5303520" y="4800600"/>
-            <a:ext cx="6156655" cy="868680"/>
+            <a:off x="5989320" y="5257800"/>
+            <a:ext cx="5468112" cy="1005840"/>
           </a:xfrm>
           <a:prstGeom prst="roundRect">
             <a:avLst/>
@@ -11481,7 +11481,7 @@
         <p:spPr>
           <a:xfrm>
             <a:off x="676656" y="1179576"/>
-            <a:ext cx="4453128" cy="4453128"/>
+            <a:ext cx="5138928" cy="5138928"/>
           </a:xfrm>
           <a:prstGeom prst="roundRect">
             <a:avLst/>
@@ -11534,7 +11534,7 @@
         <p:spPr>
           <a:xfrm>
             <a:off x="731520" y="1234440"/>
-            <a:ext cx="4343400" cy="4343400"/>
+            <a:ext cx="5029200" cy="5029200"/>
           </a:xfrm>
           <a:prstGeom prst="rect">
             <a:avLst/>
@@ -11549,8 +11549,8 @@
         </p:nvSpPr>
         <p:spPr>
           <a:xfrm>
-            <a:off x="5303520" y="1234440"/>
-            <a:ext cx="6156655" cy="3429000"/>
+            <a:off x="5989320" y="1234440"/>
+            <a:ext cx="5468112" cy="3886200"/>
           </a:xfrm>
           <a:prstGeom prst="roundRect">
             <a:avLst/>
@@ -11579,7 +11579,7 @@
           </a:fontRef>
         </p:style>
         <p:txBody>
-          <a:bodyPr rtlCol="0" anchor="ctr" wrap="square" lIns="256032" rIns="256032" tIns="182880"/>
+          <a:bodyPr rtlCol="0" anchor="ctr" wrap="square" lIns="256032" rIns="256032" tIns="201168"/>
           <a:lstStyle/>
           <a:p>
             <a:pPr algn="ctr">
@@ -11723,8 +11723,8 @@
         </p:nvSpPr>
         <p:spPr>
           <a:xfrm>
-            <a:off x="5303520" y="4800600"/>
-            <a:ext cx="6156655" cy="868680"/>
+            <a:off x="5989320" y="5257800"/>
+            <a:ext cx="5468112" cy="1005840"/>
           </a:xfrm>
           <a:prstGeom prst="roundRect">
             <a:avLst/>
@@ -12597,7 +12597,7 @@
         <p:spPr>
           <a:xfrm>
             <a:off x="676656" y="1179576"/>
-            <a:ext cx="4453128" cy="4453128"/>
+            <a:ext cx="5138928" cy="5138928"/>
           </a:xfrm>
           <a:prstGeom prst="roundRect">
             <a:avLst/>
@@ -12650,7 +12650,7 @@
         <p:spPr>
           <a:xfrm>
             <a:off x="731520" y="1234440"/>
-            <a:ext cx="4343400" cy="4343400"/>
+            <a:ext cx="5029200" cy="5029200"/>
           </a:xfrm>
           <a:prstGeom prst="rect">
             <a:avLst/>
@@ -12665,8 +12665,8 @@
         </p:nvSpPr>
         <p:spPr>
           <a:xfrm>
-            <a:off x="5303520" y="1234440"/>
-            <a:ext cx="6156655" cy="3429000"/>
+            <a:off x="5989320" y="1234440"/>
+            <a:ext cx="5468112" cy="3886200"/>
           </a:xfrm>
           <a:prstGeom prst="roundRect">
             <a:avLst/>
@@ -12695,7 +12695,7 @@
           </a:fontRef>
         </p:style>
         <p:txBody>
-          <a:bodyPr rtlCol="0" anchor="ctr" wrap="square" lIns="256032" rIns="256032" tIns="182880"/>
+          <a:bodyPr rtlCol="0" anchor="ctr" wrap="square" lIns="256032" rIns="256032" tIns="201168"/>
           <a:lstStyle/>
           <a:p>
             <a:pPr algn="ctr">
@@ -12839,8 +12839,8 @@
         </p:nvSpPr>
         <p:spPr>
           <a:xfrm>
-            <a:off x="5303520" y="4800600"/>
-            <a:ext cx="6156655" cy="868680"/>
+            <a:off x="5989320" y="5257800"/>
+            <a:ext cx="5468112" cy="1005840"/>
           </a:xfrm>
           <a:prstGeom prst="roundRect">
             <a:avLst/>

</xml_diff>

<commit_message>
feat: clarify mobile scenario dialogues, remove 總工 title, and refine debrief layout
</commit_message>
<xml_diff>
--- a/誰是文化王_備案簡報_Who_Is_Culture_King.pptx
+++ b/誰是文化王_備案簡報_Who_Is_Culture_King.pptx
@@ -1287,7 +1287,7 @@
           <a:lstStyle/>
           <a:p>
             <a:r>
-              <a:t>【引導提示】為什麼總工會上不反對會後不動？為什麼總工要嚴懲越級寫信的年輕工程師？</a:t>
+              <a:t>【引導提示】為什麼技術主管會上不反對會後不動？為什麼技術主管要嚴懲越級寫信的年輕工程師？</a:t>
             </a:r>
           </a:p>
         </p:txBody>
@@ -10489,7 +10489,7 @@
               </a:defRPr>
             </a:pPr>
             <a:r>
-              <a:t>【會議現場】</a:t>
+              <a:t>【週一全體大會】</a:t>
             </a:r>
           </a:p>
           <a:p>
@@ -10504,7 +10504,7 @@
               </a:defRPr>
             </a:pPr>
             <a:r>
-              <a:t>你：「縮短老練測試工時 20%，大家有沒有異議？」全場低頭抄筆記，一片沉默……</a:t>
+              <a:t>你：「提議縮短高溫測試工時兩成，大家有無異議？」全場低頭抄筆記，一片沉默……</a:t>
             </a:r>
           </a:p>
           <a:p>
@@ -10519,7 +10519,7 @@
               </a:defRPr>
             </a:pPr>
             <a:r>
-              <a:t>【資深總工】</a:t>
+              <a:t>【技術主管態度】</a:t>
             </a:r>
           </a:p>
           <a:p>
@@ -10534,7 +10534,7 @@
               </a:defRPr>
             </a:pPr>
             <a:r>
-              <a:t>總工微笑：「我們會盡力研究。」你心想：太好了，大家都同意！</a:t>
+              <a:t>技術主管微笑：「我們會盡力研究。」你心想：太好了，大家都同意！</a:t>
             </a:r>
           </a:p>
           <a:p>
@@ -10549,7 +10549,7 @@
               </a:defRPr>
             </a:pPr>
             <a:r>
-              <a:t>【週三清晨】</a:t>
+              <a:t>【週三產線現場】</a:t>
             </a:r>
           </a:p>
           <a:p>
@@ -10564,7 +10564,7 @@
               </a:defRPr>
             </a:pPr>
             <a:r>
-              <a:t>來到產線，測試爐工時仍為 100%，產線完全沒動！</a:t>
+              <a:t>來到產線，測試爐工時仍為百分之百，產線完全沒動！</a:t>
             </a:r>
           </a:p>
           <a:p>
@@ -10579,7 +10579,7 @@
               </a:defRPr>
             </a:pPr>
             <a:r>
-              <a:t>【茶水間外】</a:t>
+              <a:t>【茶水間外衝突】</a:t>
             </a:r>
           </a:p>
           <a:p>
@@ -10594,7 +10594,7 @@
               </a:defRPr>
             </a:pPr>
             <a:r>
-              <a:t>總工嚴斥昨晚寫私信給你的年輕人：「不懂規矩！破壞團隊程序！」</a:t>
+              <a:t>技術主管嚴厲斥責昨晚寫私信給你的年輕人：「不懂規矩！破壞團隊程序！」</a:t>
             </a:r>
           </a:p>
         </p:txBody>

</xml_diff>

<commit_message>
feat: make decision prompts purely situational without spoiling cultural quadrant answers
</commit_message>
<xml_diff>
--- a/誰是文化王_備案簡報_Who_Is_Culture_King.pptx
+++ b/誰是文化王_備案簡報_Who_Is_Culture_King.pptx
@@ -1497,7 +1497,7 @@
           <a:lstStyle/>
           <a:p>
             <a:r>
-              <a:t>【計分引導】靶心座標為 (84, 18)。交期只剩 4 小時的危機中，尋求共識會被視為卸責。</a:t>
+              <a:t>【計分引導】靶心座標為 (84, 18)。交期只剩四小時的危機中，尋求共識會被視為卸責。</a:t>
             </a:r>
           </a:p>
         </p:txBody>
@@ -1567,7 +1567,7 @@
           <a:lstStyle/>
           <a:p>
             <a:r>
-              <a:t>【引導提示】年輕人敢當面挑戰主管反映極低權力距離；先上線有問題再修補反映小 d 速決思維。</a:t>
+              <a:t>【引導提示】年輕人敢當面挑戰主管反映極低權力距離；先上線有問題再修補反映小速決思維。</a:t>
             </a:r>
           </a:p>
         </p:txBody>
@@ -5648,7 +5648,7 @@
               </a:defRPr>
             </a:pPr>
             <a:r>
-              <a:t>矽谷敏捷試錯模式，組織極度扁平，決策採小寫 d 快速推進與動態修補。</a:t>
+              <a:t>矽谷敏捷試錯模式，組織極度扁平，決策採快速推進與動態修補。</a:t>
             </a:r>
           </a:p>
           <a:p>
@@ -5977,7 +5977,7 @@
               </a:defRPr>
             </a:pPr>
             <a:r>
-              <a:t>【後台突發】</a:t>
+              <a:t>【發表會前兩小時】</a:t>
             </a:r>
           </a:p>
           <a:p>
@@ -5992,7 +5992,7 @@
               </a:defRPr>
             </a:pPr>
             <a:r>
-              <a:t>全球發表會倒數 02:00:00，最大客戶技術長帶著兩名年輕測試員突然直接走進後台。</a:t>
+              <a:t>全球發表會倒數兩小時，最大客戶技術長帶著兩名年輕測試員突然直接走進後台。</a:t>
             </a:r>
           </a:p>
           <a:p>
@@ -6007,7 +6007,7 @@
               </a:defRPr>
             </a:pPr>
             <a:r>
-              <a:t>【報告攤牌】</a:t>
+              <a:t>【現場攤牌報告】</a:t>
             </a:r>
           </a:p>
           <a:p>
@@ -6037,7 +6037,7 @@
               </a:defRPr>
             </a:pPr>
             <a:r>
-              <a:t>【基層聲明】</a:t>
+              <a:t>【基層堅持把關】</a:t>
             </a:r>
           </a:p>
           <a:p>
@@ -6067,7 +6067,7 @@
               </a:defRPr>
             </a:pPr>
             <a:r>
-              <a:t>【拒絕妥協】</a:t>
+              <a:t>【拒絕私下妥協】</a:t>
             </a:r>
           </a:p>
           <a:p>
@@ -6134,7 +6134,7 @@
               </a:defRPr>
             </a:pPr>
             <a:r>
-              <a:t>⏱️ 決策課題：面對基層擁有完全否決權、堅持透明共審的團隊，你的領導決策座標應落在哪裡？</a:t>
+              <a:t>⏱️ 決策課題：發表會倒數兩小時，面對客戶技術員在後台強硬阻擋放行，你的領導決策座標落點在哪裡？</a:t>
             </a:r>
           </a:p>
         </p:txBody>
@@ -10646,7 +10646,7 @@
               </a:defRPr>
             </a:pPr>
             <a:r>
-              <a:t>⏱️ 決策課題：面對表面和諧、實則嚴守階層與私下共識的團隊，你的領導決策座標在哪裡？</a:t>
+              <a:t>⏱️ 決策課題：面對會議全員沉默抄筆記、會後產線完全不動的局面，你的領導決策座標落點在哪裡？</a:t>
             </a:r>
           </a:p>
         </p:txBody>
@@ -11605,7 +11605,7 @@
               </a:defRPr>
             </a:pPr>
             <a:r>
-              <a:t>【夜班 02:10】</a:t>
+              <a:t>【凌晨兩點十分】</a:t>
             </a:r>
           </a:p>
           <a:p>
@@ -11620,7 +11620,7 @@
               </a:defRPr>
             </a:pPr>
             <a:r>
-              <a:t>塗佈機良率暴跌至 48%！產線領班大驚失色。</a:t>
+              <a:t>塗佈機良率雪崩跌至四成八！產線領班大驚失色。</a:t>
             </a:r>
           </a:p>
           <a:p>
@@ -11635,7 +11635,7 @@
               </a:defRPr>
             </a:pPr>
             <a:r>
-              <a:t>【現場下令】</a:t>
+              <a:t>【廠長強制停機】</a:t>
             </a:r>
           </a:p>
           <a:p>
@@ -11665,7 +11665,7 @@
               </a:defRPr>
             </a:pPr>
             <a:r>
-              <a:t>【群組爭吵】</a:t>
+              <a:t>【群組爭吵甩鍋】</a:t>
             </a:r>
           </a:p>
           <a:p>
@@ -11695,7 +11695,7 @@
               </a:defRPr>
             </a:pPr>
             <a:r>
-              <a:t>【領班求救】</a:t>
+              <a:t>【產線領班求救】</a:t>
             </a:r>
           </a:p>
           <a:p>
@@ -11762,7 +11762,7 @@
               </a:defRPr>
             </a:pPr>
             <a:r>
-              <a:t>⏱️ 決策課題：距離交貨剩 4 小時，團隊恐懼承擔責任，你的領導決策座標應落在哪裡？</a:t>
+              <a:t>⏱️ 決策課題：距離交貨剩四小時，面對團隊恐懼責任且無人敢動手，你的領導決策座標落點在哪裡？</a:t>
             </a:r>
           </a:p>
         </p:txBody>
@@ -12721,7 +12721,7 @@
               </a:defRPr>
             </a:pPr>
             <a:r>
-              <a:t>【封版倒數 36h】</a:t>
+              <a:t>【封版倒數三十六小時】</a:t>
             </a:r>
           </a:p>
           <a:p>
@@ -12751,7 +12751,7 @@
               </a:defRPr>
             </a:pPr>
             <a:r>
-              <a:t>【激進提案】</a:t>
+              <a:t>【大膽激進提案】</a:t>
             </a:r>
           </a:p>
           <a:p>
@@ -12781,7 +12781,7 @@
               </a:defRPr>
             </a:pPr>
             <a:r>
-              <a:t>【全員起鬨】</a:t>
+              <a:t>【團隊全員起鬨】</a:t>
             </a:r>
           </a:p>
           <a:p>
@@ -12811,7 +12811,7 @@
               </a:defRPr>
             </a:pPr>
             <a:r>
-              <a:t>【品保沉默】</a:t>
+              <a:t>【品保主管沉默】</a:t>
             </a:r>
           </a:p>
           <a:p>
@@ -12826,7 +12826,7 @@
               </a:defRPr>
             </a:pPr>
             <a:r>
-              <a:t>品保主管面色凝重，沉默看向你等待定奪……倒數只剩 35:58:40！</a:t>
+              <a:t>品保主管面色凝重，沉默看向你等待定奪……倒數只剩三十五小時！</a:t>
             </a:r>
           </a:p>
         </p:txBody>
@@ -12878,7 +12878,7 @@
               </a:defRPr>
             </a:pPr>
             <a:r>
-              <a:t>⏱️ 決策課題：面對扁平直接、崇尚速度勝於完美的團隊，你的決策座標落點在哪裡？</a:t>
+              <a:t>⏱️ 決策課題：面對成員大膽挑戰既有架構並要求立即上線，你的領導決策座標落點在哪裡？</a:t>
             </a:r>
           </a:p>
         </p:txBody>

</xml_diff>

<commit_message>
feat: enlarge debrief text font and label representative countries for all quadrants
</commit_message>
<xml_diff>
--- a/誰是文化王_備案簡報_Who_Is_Culture_King.pptx
+++ b/誰是文化王_備案簡報_Who_Is_Culture_King.pptx
@@ -5231,6 +5231,21 @@
           <a:p>
             <a:pPr algn="ctr">
               <a:spcBef>
+                <a:spcPts val="400"/>
+              </a:spcBef>
+              <a:defRPr sz="1300" b="1">
+                <a:solidFill>
+                  <a:srgbClr val="93C5FD"/>
+                </a:solidFill>
+              </a:defRPr>
+            </a:pPr>
+            <a:r>
+              <a:t>【代表國家：美國（矽谷）、澳洲、加拿大、英國】</a:t>
+            </a:r>
+          </a:p>
+          <a:p>
+            <a:pPr algn="ctr">
+              <a:spcBef>
                 <a:spcPts val="600"/>
               </a:spcBef>
               <a:defRPr sz="1200">
@@ -5607,11 +5622,11 @@
           </a:fontRef>
         </p:style>
         <p:txBody>
-          <a:bodyPr rtlCol="0" anchor="ctr" wrap="square" lIns="365760" rIns="365760" tIns="411480"/>
+          <a:bodyPr rtlCol="0" anchor="ctr" wrap="square" lIns="365760" rIns="365760" tIns="365760"/>
           <a:lstStyle/>
           <a:p>
             <a:pPr algn="ctr">
-              <a:defRPr sz="1900" b="1">
+              <a:defRPr sz="2000" b="1">
                 <a:solidFill>
                   <a:srgbClr val="1E293B"/>
                 </a:solidFill>
@@ -5624,9 +5639,24 @@
           <a:p>
             <a:pPr>
               <a:spcBef>
-                <a:spcPts val="1800"/>
+                <a:spcPts val="400"/>
               </a:spcBef>
-              <a:defRPr sz="1600" b="1">
+              <a:defRPr sz="1500" b="1">
+                <a:solidFill>
+                  <a:srgbClr val="0284C7"/>
+                </a:solidFill>
+              </a:defRPr>
+            </a:pPr>
+            <a:r>
+              <a:t>代表國家：美國（矽谷）、澳洲、加拿大、英國</a:t>
+            </a:r>
+          </a:p>
+          <a:p>
+            <a:pPr>
+              <a:spcBef>
+                <a:spcPts val="1600"/>
+              </a:spcBef>
+              <a:defRPr sz="1700" b="1">
                 <a:solidFill>
                   <a:srgbClr val="1E293B"/>
                 </a:solidFill>
@@ -5641,7 +5671,7 @@
               <a:lnSpc>
                 <a:spcPct val="135000"/>
               </a:lnSpc>
-              <a:defRPr sz="1300">
+              <a:defRPr sz="1450">
                 <a:solidFill>
                   <a:srgbClr val="475569"/>
                 </a:solidFill>
@@ -5654,9 +5684,9 @@
           <a:p>
             <a:pPr>
               <a:spcBef>
-                <a:spcPts val="1800"/>
+                <a:spcPts val="1600"/>
               </a:spcBef>
-              <a:defRPr sz="1600" b="1">
+              <a:defRPr sz="1700" b="1">
                 <a:solidFill>
                   <a:srgbClr val="1E293B"/>
                 </a:solidFill>
@@ -5671,7 +5701,7 @@
               <a:lnSpc>
                 <a:spcPct val="135000"/>
               </a:lnSpc>
-              <a:defRPr sz="1300">
+              <a:defRPr sz="1450">
                 <a:solidFill>
                   <a:srgbClr val="475569"/>
                 </a:solidFill>
@@ -5684,9 +5714,9 @@
           <a:p>
             <a:pPr>
               <a:spcBef>
-                <a:spcPts val="1800"/>
+                <a:spcPts val="1600"/>
               </a:spcBef>
-              <a:defRPr sz="1600" b="1">
+              <a:defRPr sz="1700" b="1">
                 <a:solidFill>
                   <a:srgbClr val="1E293B"/>
                 </a:solidFill>
@@ -5701,7 +5731,7 @@
               <a:lnSpc>
                 <a:spcPct val="135000"/>
               </a:lnSpc>
-              <a:defRPr sz="1300">
+              <a:defRPr sz="1450">
                 <a:solidFill>
                   <a:srgbClr val="475569"/>
                 </a:solidFill>
@@ -6347,6 +6377,21 @@
           <a:p>
             <a:pPr algn="ctr">
               <a:spcBef>
+                <a:spcPts val="400"/>
+              </a:spcBef>
+              <a:defRPr sz="1300" b="1">
+                <a:solidFill>
+                  <a:srgbClr val="93C5FD"/>
+                </a:solidFill>
+              </a:defRPr>
+            </a:pPr>
+            <a:r>
+              <a:t>【代表國家：荷蘭、瑞典、丹麥、挪威（北歐與低地國）】</a:t>
+            </a:r>
+          </a:p>
+          <a:p>
+            <a:pPr algn="ctr">
+              <a:spcBef>
                 <a:spcPts val="600"/>
               </a:spcBef>
               <a:defRPr sz="1200">
@@ -6723,11 +6768,11 @@
           </a:fontRef>
         </p:style>
         <p:txBody>
-          <a:bodyPr rtlCol="0" anchor="ctr" wrap="square" lIns="365760" rIns="365760" tIns="411480"/>
+          <a:bodyPr rtlCol="0" anchor="ctr" wrap="square" lIns="365760" rIns="365760" tIns="365760"/>
           <a:lstStyle/>
           <a:p>
             <a:pPr algn="ctr">
-              <a:defRPr sz="1900" b="1">
+              <a:defRPr sz="2000" b="1">
                 <a:solidFill>
                   <a:srgbClr val="1E293B"/>
                 </a:solidFill>
@@ -6740,9 +6785,24 @@
           <a:p>
             <a:pPr>
               <a:spcBef>
-                <a:spcPts val="1800"/>
+                <a:spcPts val="400"/>
               </a:spcBef>
-              <a:defRPr sz="1600" b="1">
+              <a:defRPr sz="1500" b="1">
+                <a:solidFill>
+                  <a:srgbClr val="0284C7"/>
+                </a:solidFill>
+              </a:defRPr>
+            </a:pPr>
+            <a:r>
+              <a:t>代表國家：荷蘭、瑞典、丹麥、挪威（北歐與低地國）</a:t>
+            </a:r>
+          </a:p>
+          <a:p>
+            <a:pPr>
+              <a:spcBef>
+                <a:spcPts val="1600"/>
+              </a:spcBef>
+              <a:defRPr sz="1700" b="1">
                 <a:solidFill>
                   <a:srgbClr val="1E293B"/>
                 </a:solidFill>
@@ -6757,7 +6817,7 @@
               <a:lnSpc>
                 <a:spcPct val="135000"/>
               </a:lnSpc>
-              <a:defRPr sz="1300">
+              <a:defRPr sz="1450">
                 <a:solidFill>
                   <a:srgbClr val="475569"/>
                 </a:solidFill>
@@ -6770,9 +6830,9 @@
           <a:p>
             <a:pPr>
               <a:spcBef>
-                <a:spcPts val="1800"/>
+                <a:spcPts val="1600"/>
               </a:spcBef>
-              <a:defRPr sz="1600" b="1">
+              <a:defRPr sz="1700" b="1">
                 <a:solidFill>
                   <a:srgbClr val="1E293B"/>
                 </a:solidFill>
@@ -6787,7 +6847,7 @@
               <a:lnSpc>
                 <a:spcPct val="135000"/>
               </a:lnSpc>
-              <a:defRPr sz="1300">
+              <a:defRPr sz="1450">
                 <a:solidFill>
                   <a:srgbClr val="475569"/>
                 </a:solidFill>
@@ -6800,9 +6860,9 @@
           <a:p>
             <a:pPr>
               <a:spcBef>
-                <a:spcPts val="1800"/>
+                <a:spcPts val="1600"/>
               </a:spcBef>
-              <a:defRPr sz="1600" b="1">
+              <a:defRPr sz="1700" b="1">
                 <a:solidFill>
                   <a:srgbClr val="1E293B"/>
                 </a:solidFill>
@@ -6817,7 +6877,7 @@
               <a:lnSpc>
                 <a:spcPct val="135000"/>
               </a:lnSpc>
-              <a:defRPr sz="1300">
+              <a:defRPr sz="1450">
                 <a:solidFill>
                   <a:srgbClr val="475569"/>
                 </a:solidFill>
@@ -10859,6 +10919,21 @@
           <a:p>
             <a:pPr algn="ctr">
               <a:spcBef>
+                <a:spcPts val="400"/>
+              </a:spcBef>
+              <a:defRPr sz="1300" b="1">
+                <a:solidFill>
+                  <a:srgbClr val="93C5FD"/>
+                </a:solidFill>
+              </a:defRPr>
+            </a:pPr>
+            <a:r>
+              <a:t>【代表國家：日本、韓國】</a:t>
+            </a:r>
+          </a:p>
+          <a:p>
+            <a:pPr algn="ctr">
+              <a:spcBef>
                 <a:spcPts val="600"/>
               </a:spcBef>
               <a:defRPr sz="1200">
@@ -11235,11 +11310,11 @@
           </a:fontRef>
         </p:style>
         <p:txBody>
-          <a:bodyPr rtlCol="0" anchor="ctr" wrap="square" lIns="365760" rIns="365760" tIns="411480"/>
+          <a:bodyPr rtlCol="0" anchor="ctr" wrap="square" lIns="365760" rIns="365760" tIns="365760"/>
           <a:lstStyle/>
           <a:p>
             <a:pPr algn="ctr">
-              <a:defRPr sz="1900" b="1">
+              <a:defRPr sz="2000" b="1">
                 <a:solidFill>
                   <a:srgbClr val="1E293B"/>
                 </a:solidFill>
@@ -11252,9 +11327,24 @@
           <a:p>
             <a:pPr>
               <a:spcBef>
-                <a:spcPts val="1800"/>
+                <a:spcPts val="400"/>
               </a:spcBef>
-              <a:defRPr sz="1600" b="1">
+              <a:defRPr sz="1500" b="1">
+                <a:solidFill>
+                  <a:srgbClr val="0284C7"/>
+                </a:solidFill>
+              </a:defRPr>
+            </a:pPr>
+            <a:r>
+              <a:t>代表國家：日本、韓國</a:t>
+            </a:r>
+          </a:p>
+          <a:p>
+            <a:pPr>
+              <a:spcBef>
+                <a:spcPts val="1600"/>
+              </a:spcBef>
+              <a:defRPr sz="1700" b="1">
                 <a:solidFill>
                   <a:srgbClr val="1E293B"/>
                 </a:solidFill>
@@ -11269,7 +11359,7 @@
               <a:lnSpc>
                 <a:spcPct val="135000"/>
               </a:lnSpc>
-              <a:defRPr sz="1300">
+              <a:defRPr sz="1450">
                 <a:solidFill>
                   <a:srgbClr val="475569"/>
                 </a:solidFill>
@@ -11282,9 +11372,9 @@
           <a:p>
             <a:pPr>
               <a:spcBef>
-                <a:spcPts val="1800"/>
+                <a:spcPts val="1600"/>
               </a:spcBef>
-              <a:defRPr sz="1600" b="1">
+              <a:defRPr sz="1700" b="1">
                 <a:solidFill>
                   <a:srgbClr val="1E293B"/>
                 </a:solidFill>
@@ -11299,7 +11389,7 @@
               <a:lnSpc>
                 <a:spcPct val="135000"/>
               </a:lnSpc>
-              <a:defRPr sz="1300">
+              <a:defRPr sz="1450">
                 <a:solidFill>
                   <a:srgbClr val="475569"/>
                 </a:solidFill>
@@ -11312,9 +11402,9 @@
           <a:p>
             <a:pPr>
               <a:spcBef>
-                <a:spcPts val="1800"/>
+                <a:spcPts val="1600"/>
               </a:spcBef>
-              <a:defRPr sz="1600" b="1">
+              <a:defRPr sz="1700" b="1">
                 <a:solidFill>
                   <a:srgbClr val="1E293B"/>
                 </a:solidFill>
@@ -11329,7 +11419,7 @@
               <a:lnSpc>
                 <a:spcPct val="135000"/>
               </a:lnSpc>
-              <a:defRPr sz="1300">
+              <a:defRPr sz="1450">
                 <a:solidFill>
                   <a:srgbClr val="475569"/>
                 </a:solidFill>
@@ -11975,6 +12065,21 @@
           <a:p>
             <a:pPr algn="ctr">
               <a:spcBef>
+                <a:spcPts val="400"/>
+              </a:spcBef>
+              <a:defRPr sz="1300" b="1">
+                <a:solidFill>
+                  <a:srgbClr val="93C5FD"/>
+                </a:solidFill>
+              </a:defRPr>
+            </a:pPr>
+            <a:r>
+              <a:t>【代表國家：中國、俄羅斯、印度、沙烏地阿拉伯】</a:t>
+            </a:r>
+          </a:p>
+          <a:p>
+            <a:pPr algn="ctr">
+              <a:spcBef>
                 <a:spcPts val="600"/>
               </a:spcBef>
               <a:defRPr sz="1200">
@@ -12351,11 +12456,11 @@
           </a:fontRef>
         </p:style>
         <p:txBody>
-          <a:bodyPr rtlCol="0" anchor="ctr" wrap="square" lIns="365760" rIns="365760" tIns="411480"/>
+          <a:bodyPr rtlCol="0" anchor="ctr" wrap="square" lIns="365760" rIns="365760" tIns="365760"/>
           <a:lstStyle/>
           <a:p>
             <a:pPr algn="ctr">
-              <a:defRPr sz="1900" b="1">
+              <a:defRPr sz="2000" b="1">
                 <a:solidFill>
                   <a:srgbClr val="1E293B"/>
                 </a:solidFill>
@@ -12368,9 +12473,24 @@
           <a:p>
             <a:pPr>
               <a:spcBef>
-                <a:spcPts val="1800"/>
+                <a:spcPts val="400"/>
               </a:spcBef>
-              <a:defRPr sz="1600" b="1">
+              <a:defRPr sz="1500" b="1">
+                <a:solidFill>
+                  <a:srgbClr val="0284C7"/>
+                </a:solidFill>
+              </a:defRPr>
+            </a:pPr>
+            <a:r>
+              <a:t>代表國家：中國、俄羅斯、印度、沙烏地阿拉伯</a:t>
+            </a:r>
+          </a:p>
+          <a:p>
+            <a:pPr>
+              <a:spcBef>
+                <a:spcPts val="1600"/>
+              </a:spcBef>
+              <a:defRPr sz="1700" b="1">
                 <a:solidFill>
                   <a:srgbClr val="1E293B"/>
                 </a:solidFill>
@@ -12385,7 +12505,7 @@
               <a:lnSpc>
                 <a:spcPct val="135000"/>
               </a:lnSpc>
-              <a:defRPr sz="1300">
+              <a:defRPr sz="1450">
                 <a:solidFill>
                   <a:srgbClr val="475569"/>
                 </a:solidFill>
@@ -12398,9 +12518,9 @@
           <a:p>
             <a:pPr>
               <a:spcBef>
-                <a:spcPts val="1800"/>
+                <a:spcPts val="1600"/>
               </a:spcBef>
-              <a:defRPr sz="1600" b="1">
+              <a:defRPr sz="1700" b="1">
                 <a:solidFill>
                   <a:srgbClr val="1E293B"/>
                 </a:solidFill>
@@ -12415,7 +12535,7 @@
               <a:lnSpc>
                 <a:spcPct val="135000"/>
               </a:lnSpc>
-              <a:defRPr sz="1300">
+              <a:defRPr sz="1450">
                 <a:solidFill>
                   <a:srgbClr val="475569"/>
                 </a:solidFill>
@@ -12428,9 +12548,9 @@
           <a:p>
             <a:pPr>
               <a:spcBef>
-                <a:spcPts val="1800"/>
+                <a:spcPts val="1600"/>
               </a:spcBef>
-              <a:defRPr sz="1600" b="1">
+              <a:defRPr sz="1700" b="1">
                 <a:solidFill>
                   <a:srgbClr val="1E293B"/>
                 </a:solidFill>
@@ -12445,7 +12565,7 @@
               <a:lnSpc>
                 <a:spcPct val="135000"/>
               </a:lnSpc>
-              <a:defRPr sz="1300">
+              <a:defRPr sz="1450">
                 <a:solidFill>
                   <a:srgbClr val="475569"/>
                 </a:solidFill>

</xml_diff>

<commit_message>
feat: update case 1 dialogue to employees privately complaining about breaking rules and lack of pre-meeting consultation
</commit_message>
<xml_diff>
--- a/誰是文化王_備案簡報_Who_Is_Culture_King.pptx
+++ b/誰是文化王_備案簡報_Who_Is_Culture_King.pptx
@@ -1287,7 +1287,7 @@
           <a:lstStyle/>
           <a:p>
             <a:r>
-              <a:t>【引導提示】為什麼技術主管會上不反對會後不動？為什麼技術主管要嚴懲越級寫信的年輕工程師？</a:t>
+              <a:t>【引導提示】為什麼技術主管會上不反對會後不動？為什麼員工私下批評未在會議前討論是破壞規則？</a:t>
             </a:r>
           </a:p>
         </p:txBody>
@@ -10639,7 +10639,7 @@
               </a:defRPr>
             </a:pPr>
             <a:r>
-              <a:t>【茶水間外衝突】</a:t>
+              <a:t>【茶水間外議論】</a:t>
             </a:r>
           </a:p>
           <a:p>
@@ -10654,7 +10654,7 @@
               </a:defRPr>
             </a:pPr>
             <a:r>
-              <a:t>技術主管嚴厲斥責昨晚寫私信給你的年輕人：「不懂規矩！破壞團隊程序！」</a:t>
+              <a:t>員工私下罵你破壞規則：「沒有在會議前先跟大家討論，根本不尊重專業！」</a:t>
             </a:r>
           </a:p>
         </p:txBody>

</xml_diff>

<commit_message>
feat: align representative countries strictly with literature slide 36 & 44
</commit_message>
<xml_diff>
--- a/誰是文化王_備案簡報_Who_Is_Culture_King.pptx
+++ b/誰是文化王_備案簡報_Who_Is_Culture_King.pptx
@@ -5240,7 +5240,7 @@
               </a:defRPr>
             </a:pPr>
             <a:r>
-              <a:t>【代表國家：美國（矽谷）、澳洲、加拿大、英國】</a:t>
+              <a:t>【代表國家：美國、英國】</a:t>
             </a:r>
           </a:p>
           <a:p>
@@ -5648,7 +5648,7 @@
               </a:defRPr>
             </a:pPr>
             <a:r>
-              <a:t>代表國家：美國（矽谷）、澳洲、加拿大、英國</a:t>
+              <a:t>代表國家：美國、英國</a:t>
             </a:r>
           </a:p>
           <a:p>
@@ -6386,7 +6386,7 @@
               </a:defRPr>
             </a:pPr>
             <a:r>
-              <a:t>【代表國家：荷蘭、瑞典、丹麥、挪威（北歐與低地國）】</a:t>
+              <a:t>【代表國家：丹麥、荷蘭】</a:t>
             </a:r>
           </a:p>
           <a:p>
@@ -6794,7 +6794,7 @@
               </a:defRPr>
             </a:pPr>
             <a:r>
-              <a:t>代表國家：荷蘭、瑞典、丹麥、挪威（北歐與低地國）</a:t>
+              <a:t>代表國家：丹麥、荷蘭</a:t>
             </a:r>
           </a:p>
           <a:p>
@@ -7094,7 +7094,7 @@
               </a:defRPr>
             </a:pPr>
             <a:r>
-              <a:t>【日本、韓國】</a:t>
+              <a:t>【日本、德國】</a:t>
             </a:r>
           </a:p>
           <a:p>
@@ -7221,7 +7221,7 @@
               </a:defRPr>
             </a:pPr>
             <a:r>
-              <a:t>【荷蘭、北歐各國】</a:t>
+              <a:t>【丹麥、荷蘭】</a:t>
             </a:r>
           </a:p>
           <a:p>
@@ -7348,7 +7348,7 @@
               </a:defRPr>
             </a:pPr>
             <a:r>
-              <a:t>【美國矽谷、英國新創】</a:t>
+              <a:t>【美國、英國】</a:t>
             </a:r>
           </a:p>
           <a:p>
@@ -7360,7 +7360,7 @@
               </a:defRPr>
             </a:pPr>
             <a:r>
-              <a:t>• 決策機制：小 d 敏捷試錯</a:t>
+              <a:t>• 決策機制：小速決敏捷試錯</a:t>
             </a:r>
           </a:p>
           <a:p>
@@ -7475,7 +7475,7 @@
               </a:defRPr>
             </a:pPr>
             <a:r>
-              <a:t>【中國工廠、法國、印度】</a:t>
+              <a:t>【中國、法國】</a:t>
             </a:r>
           </a:p>
           <a:p>
@@ -9482,7 +9482,7 @@
               </a:defRPr>
             </a:pPr>
             <a:r>
-              <a:t>【日本、韓國】嚴明職級尊重與全員共識並存。正式會議僅為形式用印，真正的決策必須在會前依職級序列由下而上完成「會前私下摸底（根回）」。</a:t>
+              <a:t>【日本、德國】嚴明職級尊重與全員共識並存。正式會議僅為形式用印，真正的決策必須在會前依職級序列由下而上完成「會前私下摸底（根回）」。</a:t>
             </a:r>
           </a:p>
         </p:txBody>
@@ -9548,7 +9548,7 @@
               </a:defRPr>
             </a:pPr>
             <a:r>
-              <a:t>【荷蘭、北歐各國】基層與主管平起平坐，人人皆有一票否決權。領導者為「促進者」，追求刻在石碑上的神聖大承諾（大承諾）。</a:t>
+              <a:t>【丹麥、荷蘭】基層與主管平起平坐，人人皆有一票否決權。領導者為「促進者」，追求刻在石碑上的神聖大承諾。</a:t>
             </a:r>
           </a:p>
         </p:txBody>
@@ -9614,7 +9614,7 @@
               </a:defRPr>
             </a:pPr>
             <a:r>
-              <a:t>【美國矽谷、英國新創】扁平極客文化，鼓勵直抒己見甚至挑戰主管；但決策採「小速決」模式，先試跑、後續動態修補。</a:t>
+              <a:t>【美國、英國】扁平極客文化，鼓勵直抒己見甚至挑戰主管；但決策採「小速決」模式，先試跑、後續動態修補。</a:t>
             </a:r>
           </a:p>
         </p:txBody>
@@ -9680,7 +9680,7 @@
               </a:defRPr>
             </a:pPr>
             <a:r>
-              <a:t>【中國量產基地、法國、印度】強調最高主管威權指揮（最高指揮官模式）。危機時刻基層渴望明確指令，領導者必須一肩扛起成敗責任。</a:t>
+              <a:t>【中國、法國】強調最高主管威權指揮（最高指揮官模式）。危機時刻基層渴望明確指令，領導者必須一肩扛起成敗責任。</a:t>
             </a:r>
           </a:p>
         </p:txBody>
@@ -10928,7 +10928,7 @@
               </a:defRPr>
             </a:pPr>
             <a:r>
-              <a:t>【代表國家：日本、韓國】</a:t>
+              <a:t>【代表國家：日本、德國】</a:t>
             </a:r>
           </a:p>
           <a:p>
@@ -11336,7 +11336,7 @@
               </a:defRPr>
             </a:pPr>
             <a:r>
-              <a:t>代表國家：日本、韓國</a:t>
+              <a:t>代表國家：日本、德國</a:t>
             </a:r>
           </a:p>
           <a:p>
@@ -12074,7 +12074,7 @@
               </a:defRPr>
             </a:pPr>
             <a:r>
-              <a:t>【代表國家：中國、俄羅斯、印度、沙烏地阿拉伯】</a:t>
+              <a:t>【代表國家：中國、法國】</a:t>
             </a:r>
           </a:p>
           <a:p>
@@ -12482,7 +12482,7 @@
               </a:defRPr>
             </a:pPr>
             <a:r>
-              <a:t>代表國家：中國、俄羅斯、印度、沙烏地阿拉伯</a:t>
+              <a:t>代表國家：中國、法國</a:t>
             </a:r>
           </a:p>
           <a:p>

</xml_diff>

<commit_message>
feat: align quadrant layout strictly with literature (top: 由上而下, bottom: 共識決策, left: 較平等, right: 重階層)
</commit_message>
<xml_diff>
--- a/誰是文化王_備案簡報_Who_Is_Culture_King.pptx
+++ b/誰是文化王_備案簡報_Who_Is_Culture_King.pptx
@@ -587,7 +587,7 @@
           <a:lstStyle/>
           <a:p>
             <a:r>
-              <a:t>【計分引導】靶心座標為 (22, 24)。引導學員理解敏捷文化中的小速決思維。</a:t>
+              <a:t>【計分引導】靶心座標為 (22, 76)。引導學員理解敏捷文化中的小速決思維。</a:t>
             </a:r>
           </a:p>
         </p:txBody>
@@ -727,7 +727,7 @@
           <a:lstStyle/>
           <a:p>
             <a:r>
-              <a:t>【計分引導】靶心座標為 (18, 85)。至此四回合已全部揭曉，請各組加總四輪總積分！</a:t>
+              <a:t>【計分引導】靶心座標為 (18, 15)。至此四回合已全部揭曉，請各組加總四輪總積分！</a:t>
             </a:r>
           </a:p>
         </p:txBody>
@@ -1357,7 +1357,7 @@
           <a:lstStyle/>
           <a:p>
             <a:r>
-              <a:t>【計分引導】靶心座標為 (78, 82)。請計算距離 d = √[(X-78)² + (Y-82)²]，得分為 100 - d。</a:t>
+              <a:t>【計分引導】靶心座標為 (78, 18)。請計算距離 d = √[(X-78)² + (Y-18)²]，得分為 100 - d。</a:t>
             </a:r>
           </a:p>
         </p:txBody>
@@ -1497,7 +1497,7 @@
           <a:lstStyle/>
           <a:p>
             <a:r>
-              <a:t>【計分引導】靶心座標為 (84, 18)。交期只剩四小時的危機中，尋求共識會被視為卸責。</a:t>
+              <a:t>【計分引導】靶心座標為 (84, 82)。交期只剩四小時的危機中，尋求共識會被視為卸責。</a:t>
             </a:r>
           </a:p>
         </p:txBody>
@@ -5149,7 +5149,7 @@
               </a:defRPr>
             </a:pPr>
             <a:r>
-              <a:t>案例三 答案揭曉 · 第三象限（左下：橫軸 22，縱軸 24）</a:t>
+              <a:t>案例三 答案揭曉 · 左上象限（左上：橫軸 22，縱軸 76）</a:t>
             </a:r>
           </a:p>
         </p:txBody>
@@ -5201,7 +5201,7 @@
               </a:defRPr>
             </a:pPr>
             <a:r>
-              <a:t>正確答案（左下）</a:t>
+              <a:t>正確答案（左上）</a:t>
             </a:r>
           </a:p>
           <a:p>
@@ -5213,7 +5213,7 @@
               </a:defRPr>
             </a:pPr>
             <a:r>
-              <a:t>第三象限</a:t>
+              <a:t>左上象限</a:t>
             </a:r>
           </a:p>
           <a:p>
@@ -5225,7 +5225,7 @@
               </a:defRPr>
             </a:pPr>
             <a:r>
-              <a:t>平等主義 × 由上而下速決</a:t>
+              <a:t>平等 × 由上而下</a:t>
             </a:r>
           </a:p>
           <a:p>
@@ -5255,7 +5255,7 @@
               </a:defRPr>
             </a:pPr>
             <a:r>
-              <a:t>🎯 靶心座標：(22, 24)</a:t>
+              <a:t>🎯 靶心座標：(22, 76)</a:t>
             </a:r>
           </a:p>
           <a:p>
@@ -5284,6 +5284,84 @@
         <p:spPr>
           <a:xfrm>
             <a:off x="1645920" y="4114800"/>
+            <a:ext cx="1051560" cy="1051560"/>
+          </a:xfrm>
+          <a:prstGeom prst="roundRect">
+            <a:avLst/>
+          </a:prstGeom>
+          <a:solidFill>
+            <a:srgbClr val="EEF2FF"/>
+          </a:solidFill>
+          <a:ln w="12700">
+            <a:solidFill>
+              <a:srgbClr val="E2E8F0"/>
+            </a:solidFill>
+          </a:ln>
+        </p:spPr>
+        <p:style>
+          <a:lnRef idx="1">
+            <a:schemeClr val="accent1"/>
+          </a:lnRef>
+          <a:fillRef idx="3">
+            <a:schemeClr val="accent1"/>
+          </a:fillRef>
+          <a:effectRef idx="2">
+            <a:schemeClr val="accent1"/>
+          </a:effectRef>
+          <a:fontRef idx="minor">
+            <a:schemeClr val="lt1"/>
+          </a:fontRef>
+        </p:style>
+        <p:txBody>
+          <a:bodyPr rtlCol="0" anchor="ctr" wrap="square"/>
+          <a:lstStyle/>
+          <a:p>
+            <a:pPr algn="ctr">
+              <a:defRPr sz="1000" b="1">
+                <a:solidFill>
+                  <a:srgbClr val="1E293B"/>
+                </a:solidFill>
+              </a:defRPr>
+            </a:pPr>
+            <a:r>
+              <a:t>左上象限</a:t>
+            </a:r>
+          </a:p>
+          <a:p>
+            <a:pPr algn="ctr">
+              <a:defRPr sz="850">
+                <a:solidFill>
+                  <a:srgbClr val="475569"/>
+                </a:solidFill>
+              </a:defRPr>
+            </a:pPr>
+            <a:r>
+              <a:t>平等 × 由上而下</a:t>
+            </a:r>
+          </a:p>
+          <a:p>
+            <a:pPr algn="ctr">
+              <a:defRPr sz="850">
+                <a:solidFill>
+                  <a:srgbClr val="475569"/>
+                </a:solidFill>
+              </a:defRPr>
+            </a:pPr>
+            <a:r>
+              <a:t>（美國、英國）</a:t>
+            </a:r>
+          </a:p>
+        </p:txBody>
+      </p:sp>
+      <p:sp>
+        <p:nvSpPr>
+          <p:cNvPr id="7" name="Rounded Rectangle 6"/>
+          <p:cNvSpPr/>
+          <p:nvPr/>
+        </p:nvSpPr>
+        <p:spPr>
+          <a:xfrm>
+            <a:off x="2697480" y="4114800"/>
             <a:ext cx="1051560" cy="1051560"/>
           </a:xfrm>
           <a:prstGeom prst="roundRect">
@@ -5324,32 +5402,44 @@
               </a:defRPr>
             </a:pPr>
             <a:r>
-              <a:t>第二象限（左上）</a:t>
+              <a:t>右上象限</a:t>
             </a:r>
           </a:p>
           <a:p>
             <a:pPr algn="ctr">
-              <a:defRPr sz="900">
+              <a:defRPr sz="850">
                 <a:solidFill>
                   <a:srgbClr val="475569"/>
                 </a:solidFill>
               </a:defRPr>
             </a:pPr>
             <a:r>
-              <a:t>共識決策 × 平等主義</a:t>
-            </a:r>
-          </a:p>
-        </p:txBody>
-      </p:sp>
-      <p:sp>
-        <p:nvSpPr>
-          <p:cNvPr id="7" name="Rounded Rectangle 6"/>
+              <a:t>階級 × 由上而下</a:t>
+            </a:r>
+          </a:p>
+          <a:p>
+            <a:pPr algn="ctr">
+              <a:defRPr sz="850">
+                <a:solidFill>
+                  <a:srgbClr val="475569"/>
+                </a:solidFill>
+              </a:defRPr>
+            </a:pPr>
+            <a:r>
+              <a:t>（中國、法國）</a:t>
+            </a:r>
+          </a:p>
+        </p:txBody>
+      </p:sp>
+      <p:sp>
+        <p:nvSpPr>
+          <p:cNvPr id="8" name="Rounded Rectangle 7"/>
           <p:cNvSpPr/>
           <p:nvPr/>
         </p:nvSpPr>
         <p:spPr>
           <a:xfrm>
-            <a:off x="2697480" y="4114800"/>
+            <a:off x="1645920" y="5166360"/>
             <a:ext cx="1051560" cy="1051560"/>
           </a:xfrm>
           <a:prstGeom prst="roundRect">
@@ -5390,85 +5480,31 @@
               </a:defRPr>
             </a:pPr>
             <a:r>
-              <a:t>第一象限（右上）</a:t>
+              <a:t>左下象限</a:t>
             </a:r>
           </a:p>
           <a:p>
             <a:pPr algn="ctr">
-              <a:defRPr sz="900">
+              <a:defRPr sz="850">
                 <a:solidFill>
                   <a:srgbClr val="475569"/>
                 </a:solidFill>
               </a:defRPr>
             </a:pPr>
             <a:r>
-              <a:t>共識決策 × 階層制</a:t>
-            </a:r>
-          </a:p>
-        </p:txBody>
-      </p:sp>
-      <p:sp>
-        <p:nvSpPr>
-          <p:cNvPr id="8" name="Rounded Rectangle 7"/>
-          <p:cNvSpPr/>
-          <p:nvPr/>
-        </p:nvSpPr>
-        <p:spPr>
-          <a:xfrm>
-            <a:off x="1645920" y="5166360"/>
-            <a:ext cx="1051560" cy="1051560"/>
-          </a:xfrm>
-          <a:prstGeom prst="roundRect">
-            <a:avLst/>
-          </a:prstGeom>
-          <a:solidFill>
-            <a:srgbClr val="D1FAE5"/>
-          </a:solidFill>
-          <a:ln w="12700">
-            <a:solidFill>
-              <a:srgbClr val="E2E8F0"/>
-            </a:solidFill>
-          </a:ln>
-        </p:spPr>
-        <p:style>
-          <a:lnRef idx="1">
-            <a:schemeClr val="accent1"/>
-          </a:lnRef>
-          <a:fillRef idx="3">
-            <a:schemeClr val="accent1"/>
-          </a:fillRef>
-          <a:effectRef idx="2">
-            <a:schemeClr val="accent1"/>
-          </a:effectRef>
-          <a:fontRef idx="minor">
-            <a:schemeClr val="lt1"/>
-          </a:fontRef>
-        </p:style>
-        <p:txBody>
-          <a:bodyPr rtlCol="0" anchor="ctr" wrap="square"/>
-          <a:lstStyle/>
+              <a:t>平等 × 共識</a:t>
+            </a:r>
+          </a:p>
           <a:p>
             <a:pPr algn="ctr">
-              <a:defRPr sz="1000" b="1">
-                <a:solidFill>
-                  <a:srgbClr val="1E293B"/>
-                </a:solidFill>
-              </a:defRPr>
-            </a:pPr>
-            <a:r>
-              <a:t>第三象限（左下）</a:t>
-            </a:r>
-          </a:p>
-          <a:p>
-            <a:pPr algn="ctr">
-              <a:defRPr sz="900">
+              <a:defRPr sz="850">
                 <a:solidFill>
                   <a:srgbClr val="475569"/>
                 </a:solidFill>
               </a:defRPr>
             </a:pPr>
             <a:r>
-              <a:t>由上而下 × 平等主義</a:t>
+              <a:t>（丹麥、荷蘭）</a:t>
             </a:r>
           </a:p>
         </p:txBody>
@@ -5522,19 +5558,31 @@
               </a:defRPr>
             </a:pPr>
             <a:r>
-              <a:t>第四象限（右下）</a:t>
+              <a:t>右下象限</a:t>
             </a:r>
           </a:p>
           <a:p>
             <a:pPr algn="ctr">
-              <a:defRPr sz="900">
+              <a:defRPr sz="850">
                 <a:solidFill>
                   <a:srgbClr val="475569"/>
                 </a:solidFill>
               </a:defRPr>
             </a:pPr>
             <a:r>
-              <a:t>由上而下 × 階層制</a:t>
+              <a:t>階級 × 共識</a:t>
+            </a:r>
+          </a:p>
+          <a:p>
+            <a:pPr algn="ctr">
+              <a:defRPr sz="850">
+                <a:solidFill>
+                  <a:srgbClr val="475569"/>
+                </a:solidFill>
+              </a:defRPr>
+            </a:pPr>
+            <a:r>
+              <a:t>（德國、日本）</a:t>
             </a:r>
           </a:p>
         </p:txBody>
@@ -5547,7 +5595,7 @@
         </p:nvSpPr>
         <p:spPr>
           <a:xfrm>
-            <a:off x="1998878" y="5603443"/>
+            <a:off x="1998878" y="4509820"/>
             <a:ext cx="219456" cy="219456"/>
           </a:xfrm>
           <a:prstGeom prst="ellipse">
@@ -5678,7 +5726,7 @@
               </a:defRPr>
             </a:pPr>
             <a:r>
-              <a:t>矽谷敏捷試錯模式，組織極度扁平，決策採快速推進與動態修補。</a:t>
+              <a:t>敏捷試錯模式，組織極度扁平，決策採小速決快速推進與動態修補。</a:t>
             </a:r>
           </a:p>
           <a:p>
@@ -6295,7 +6343,7 @@
               </a:defRPr>
             </a:pPr>
             <a:r>
-              <a:t>案例四 答案揭曉 · 第二象限（左上：橫軸 18，縱軸 85）</a:t>
+              <a:t>案例四 答案揭曉 · 左下象限（左下：橫軸 18，縱軸 15）</a:t>
             </a:r>
           </a:p>
         </p:txBody>
@@ -6347,7 +6395,7 @@
               </a:defRPr>
             </a:pPr>
             <a:r>
-              <a:t>正確答案（左上）</a:t>
+              <a:t>正確答案（左下）</a:t>
             </a:r>
           </a:p>
           <a:p>
@@ -6359,7 +6407,7 @@
               </a:defRPr>
             </a:pPr>
             <a:r>
-              <a:t>第二象限</a:t>
+              <a:t>左下象限</a:t>
             </a:r>
           </a:p>
           <a:p>
@@ -6371,7 +6419,7 @@
               </a:defRPr>
             </a:pPr>
             <a:r>
-              <a:t>平等主義 × 共識型決策</a:t>
+              <a:t>平等 × 共識</a:t>
             </a:r>
           </a:p>
           <a:p>
@@ -6401,7 +6449,7 @@
               </a:defRPr>
             </a:pPr>
             <a:r>
-              <a:t>🎯 靶心座標：(18, 85)</a:t>
+              <a:t>🎯 靶心座標：(18, 15)</a:t>
             </a:r>
           </a:p>
           <a:p>
@@ -6430,72 +6478,6 @@
         <p:spPr>
           <a:xfrm>
             <a:off x="1645920" y="4114800"/>
-            <a:ext cx="1051560" cy="1051560"/>
-          </a:xfrm>
-          <a:prstGeom prst="roundRect">
-            <a:avLst/>
-          </a:prstGeom>
-          <a:solidFill>
-            <a:srgbClr val="EEF2FF"/>
-          </a:solidFill>
-          <a:ln w="12700">
-            <a:solidFill>
-              <a:srgbClr val="E2E8F0"/>
-            </a:solidFill>
-          </a:ln>
-        </p:spPr>
-        <p:style>
-          <a:lnRef idx="1">
-            <a:schemeClr val="accent1"/>
-          </a:lnRef>
-          <a:fillRef idx="3">
-            <a:schemeClr val="accent1"/>
-          </a:fillRef>
-          <a:effectRef idx="2">
-            <a:schemeClr val="accent1"/>
-          </a:effectRef>
-          <a:fontRef idx="minor">
-            <a:schemeClr val="lt1"/>
-          </a:fontRef>
-        </p:style>
-        <p:txBody>
-          <a:bodyPr rtlCol="0" anchor="ctr" wrap="square"/>
-          <a:lstStyle/>
-          <a:p>
-            <a:pPr algn="ctr">
-              <a:defRPr sz="1000" b="1">
-                <a:solidFill>
-                  <a:srgbClr val="1E293B"/>
-                </a:solidFill>
-              </a:defRPr>
-            </a:pPr>
-            <a:r>
-              <a:t>第二象限（左上）</a:t>
-            </a:r>
-          </a:p>
-          <a:p>
-            <a:pPr algn="ctr">
-              <a:defRPr sz="900">
-                <a:solidFill>
-                  <a:srgbClr val="475569"/>
-                </a:solidFill>
-              </a:defRPr>
-            </a:pPr>
-            <a:r>
-              <a:t>共識決策 × 平等主義</a:t>
-            </a:r>
-          </a:p>
-        </p:txBody>
-      </p:sp>
-      <p:sp>
-        <p:nvSpPr>
-          <p:cNvPr id="7" name="Rounded Rectangle 6"/>
-          <p:cNvSpPr/>
-          <p:nvPr/>
-        </p:nvSpPr>
-        <p:spPr>
-          <a:xfrm>
-            <a:off x="2697480" y="4114800"/>
             <a:ext cx="1051560" cy="1051560"/>
           </a:xfrm>
           <a:prstGeom prst="roundRect">
@@ -6536,32 +6518,44 @@
               </a:defRPr>
             </a:pPr>
             <a:r>
-              <a:t>第一象限（右上）</a:t>
+              <a:t>左上象限</a:t>
             </a:r>
           </a:p>
           <a:p>
             <a:pPr algn="ctr">
-              <a:defRPr sz="900">
+              <a:defRPr sz="850">
                 <a:solidFill>
                   <a:srgbClr val="475569"/>
                 </a:solidFill>
               </a:defRPr>
             </a:pPr>
             <a:r>
-              <a:t>共識決策 × 階層制</a:t>
-            </a:r>
-          </a:p>
-        </p:txBody>
-      </p:sp>
-      <p:sp>
-        <p:nvSpPr>
-          <p:cNvPr id="8" name="Rounded Rectangle 7"/>
+              <a:t>平等 × 由上而下</a:t>
+            </a:r>
+          </a:p>
+          <a:p>
+            <a:pPr algn="ctr">
+              <a:defRPr sz="850">
+                <a:solidFill>
+                  <a:srgbClr val="475569"/>
+                </a:solidFill>
+              </a:defRPr>
+            </a:pPr>
+            <a:r>
+              <a:t>（美國、英國）</a:t>
+            </a:r>
+          </a:p>
+        </p:txBody>
+      </p:sp>
+      <p:sp>
+        <p:nvSpPr>
+          <p:cNvPr id="7" name="Rounded Rectangle 6"/>
           <p:cNvSpPr/>
           <p:nvPr/>
         </p:nvSpPr>
         <p:spPr>
           <a:xfrm>
-            <a:off x="1645920" y="5166360"/>
+            <a:off x="2697480" y="4114800"/>
             <a:ext cx="1051560" cy="1051560"/>
           </a:xfrm>
           <a:prstGeom prst="roundRect">
@@ -6602,19 +6596,109 @@
               </a:defRPr>
             </a:pPr>
             <a:r>
-              <a:t>第三象限（左下）</a:t>
+              <a:t>右上象限</a:t>
             </a:r>
           </a:p>
           <a:p>
             <a:pPr algn="ctr">
-              <a:defRPr sz="900">
+              <a:defRPr sz="850">
                 <a:solidFill>
                   <a:srgbClr val="475569"/>
                 </a:solidFill>
               </a:defRPr>
             </a:pPr>
             <a:r>
-              <a:t>由上而下 × 平等主義</a:t>
+              <a:t>階級 × 由上而下</a:t>
+            </a:r>
+          </a:p>
+          <a:p>
+            <a:pPr algn="ctr">
+              <a:defRPr sz="850">
+                <a:solidFill>
+                  <a:srgbClr val="475569"/>
+                </a:solidFill>
+              </a:defRPr>
+            </a:pPr>
+            <a:r>
+              <a:t>（中國、法國）</a:t>
+            </a:r>
+          </a:p>
+        </p:txBody>
+      </p:sp>
+      <p:sp>
+        <p:nvSpPr>
+          <p:cNvPr id="8" name="Rounded Rectangle 7"/>
+          <p:cNvSpPr/>
+          <p:nvPr/>
+        </p:nvSpPr>
+        <p:spPr>
+          <a:xfrm>
+            <a:off x="1645920" y="5166360"/>
+            <a:ext cx="1051560" cy="1051560"/>
+          </a:xfrm>
+          <a:prstGeom prst="roundRect">
+            <a:avLst/>
+          </a:prstGeom>
+          <a:solidFill>
+            <a:srgbClr val="D1FAE5"/>
+          </a:solidFill>
+          <a:ln w="12700">
+            <a:solidFill>
+              <a:srgbClr val="E2E8F0"/>
+            </a:solidFill>
+          </a:ln>
+        </p:spPr>
+        <p:style>
+          <a:lnRef idx="1">
+            <a:schemeClr val="accent1"/>
+          </a:lnRef>
+          <a:fillRef idx="3">
+            <a:schemeClr val="accent1"/>
+          </a:fillRef>
+          <a:effectRef idx="2">
+            <a:schemeClr val="accent1"/>
+          </a:effectRef>
+          <a:fontRef idx="minor">
+            <a:schemeClr val="lt1"/>
+          </a:fontRef>
+        </p:style>
+        <p:txBody>
+          <a:bodyPr rtlCol="0" anchor="ctr" wrap="square"/>
+          <a:lstStyle/>
+          <a:p>
+            <a:pPr algn="ctr">
+              <a:defRPr sz="1000" b="1">
+                <a:solidFill>
+                  <a:srgbClr val="1E293B"/>
+                </a:solidFill>
+              </a:defRPr>
+            </a:pPr>
+            <a:r>
+              <a:t>左下象限</a:t>
+            </a:r>
+          </a:p>
+          <a:p>
+            <a:pPr algn="ctr">
+              <a:defRPr sz="850">
+                <a:solidFill>
+                  <a:srgbClr val="475569"/>
+                </a:solidFill>
+              </a:defRPr>
+            </a:pPr>
+            <a:r>
+              <a:t>平等 × 共識</a:t>
+            </a:r>
+          </a:p>
+          <a:p>
+            <a:pPr algn="ctr">
+              <a:defRPr sz="850">
+                <a:solidFill>
+                  <a:srgbClr val="475569"/>
+                </a:solidFill>
+              </a:defRPr>
+            </a:pPr>
+            <a:r>
+              <a:t>（丹麥、荷蘭）</a:t>
             </a:r>
           </a:p>
         </p:txBody>
@@ -6668,19 +6752,31 @@
               </a:defRPr>
             </a:pPr>
             <a:r>
-              <a:t>第四象限（右下）</a:t>
+              <a:t>右下象限</a:t>
             </a:r>
           </a:p>
           <a:p>
             <a:pPr algn="ctr">
-              <a:defRPr sz="900">
+              <a:defRPr sz="850">
                 <a:solidFill>
                   <a:srgbClr val="475569"/>
                 </a:solidFill>
               </a:defRPr>
             </a:pPr>
             <a:r>
-              <a:t>由上而下 × 階層制</a:t>
+              <a:t>階級 × 共識</a:t>
+            </a:r>
+          </a:p>
+          <a:p>
+            <a:pPr algn="ctr">
+              <a:defRPr sz="850">
+                <a:solidFill>
+                  <a:srgbClr val="475569"/>
+                </a:solidFill>
+              </a:defRPr>
+            </a:pPr>
+            <a:r>
+              <a:t>（德國、日本）</a:t>
             </a:r>
           </a:p>
         </p:txBody>
@@ -6693,7 +6789,7 @@
         </p:nvSpPr>
         <p:spPr>
           <a:xfrm>
-            <a:off x="1914753" y="4320540"/>
+            <a:off x="1914753" y="5792724"/>
             <a:ext cx="219456" cy="219456"/>
           </a:xfrm>
           <a:prstGeom prst="ellipse">
@@ -6824,7 +6920,7 @@
               </a:defRPr>
             </a:pPr>
             <a:r>
-              <a:t>荷蘭低地協商模式，基層工程師擁有一票否決權，追求刻在石碑上的神聖大承諾。</a:t>
+              <a:t>低地協商模式，基層工程師擁有一票否決權，追求刻在石碑上的神聖大承諾。</a:t>
             </a:r>
           </a:p>
           <a:p>
@@ -7035,6 +7131,133 @@
             <a:avLst/>
           </a:prstGeom>
           <a:solidFill>
+            <a:srgbClr val="EEF2FF"/>
+          </a:solidFill>
+          <a:ln w="19050">
+            <a:solidFill>
+              <a:srgbClr val="4F46E5"/>
+            </a:solidFill>
+          </a:ln>
+        </p:spPr>
+        <p:style>
+          <a:lnRef idx="1">
+            <a:schemeClr val="accent1"/>
+          </a:lnRef>
+          <a:fillRef idx="3">
+            <a:schemeClr val="accent1"/>
+          </a:fillRef>
+          <a:effectRef idx="2">
+            <a:schemeClr val="accent1"/>
+          </a:effectRef>
+          <a:fontRef idx="minor">
+            <a:schemeClr val="lt1"/>
+          </a:fontRef>
+        </p:style>
+        <p:txBody>
+          <a:bodyPr rtlCol="0" anchor="ctr" wrap="square" lIns="182880" tIns="182880" rIns="182880"/>
+          <a:lstStyle/>
+          <a:p>
+            <a:pPr algn="ctr">
+              <a:defRPr sz="1300" b="1">
+                <a:solidFill>
+                  <a:srgbClr val="4F46E5"/>
+                </a:solidFill>
+              </a:defRPr>
+            </a:pPr>
+            <a:r>
+              <a:t>左上象限</a:t>
+            </a:r>
+          </a:p>
+          <a:p>
+            <a:pPr>
+              <a:defRPr sz="1100" b="1">
+                <a:solidFill>
+                  <a:srgbClr val="1E293B"/>
+                </a:solidFill>
+              </a:defRPr>
+            </a:pPr>
+            <a:r>
+              <a:t>平等 × 由上而下</a:t>
+            </a:r>
+            <a:br/>
+          </a:p>
+          <a:p>
+            <a:pPr>
+              <a:defRPr sz="1000">
+                <a:solidFill>
+                  <a:srgbClr val="475569"/>
+                </a:solidFill>
+              </a:defRPr>
+            </a:pPr>
+            <a:r>
+              <a:t>【美國、英國】</a:t>
+            </a:r>
+          </a:p>
+          <a:p>
+            <a:pPr>
+              <a:defRPr sz="1000">
+                <a:solidFill>
+                  <a:srgbClr val="475569"/>
+                </a:solidFill>
+              </a:defRPr>
+            </a:pPr>
+            <a:r>
+              <a:t>• 決策機制：小速決敏捷試錯</a:t>
+            </a:r>
+          </a:p>
+          <a:p>
+            <a:pPr>
+              <a:defRPr sz="1000">
+                <a:solidFill>
+                  <a:srgbClr val="475569"/>
+                </a:solidFill>
+              </a:defRPr>
+            </a:pPr>
+            <a:r>
+              <a:t>• 領導者角色：方向定舵者 </a:t>
+            </a:r>
+          </a:p>
+          <a:p>
+            <a:pPr>
+              <a:defRPr sz="1000">
+                <a:solidFill>
+                  <a:srgbClr val="475569"/>
+                </a:solidFill>
+              </a:defRPr>
+            </a:pPr>
+            <a:r>
+              <a:t>• 關鍵動作：鼓勵平等暢所欲言，授權主管速決，後續線上動態修補。</a:t>
+            </a:r>
+          </a:p>
+          <a:p>
+            <a:pPr>
+              <a:defRPr sz="1000">
+                <a:solidFill>
+                  <a:srgbClr val="475569"/>
+                </a:solidFill>
+              </a:defRPr>
+            </a:pPr>
+            <a:r>
+              <a:t>• 致命地雷：耗費數週追求全員共識，錯失市場先機。</a:t>
+            </a:r>
+          </a:p>
+        </p:txBody>
+      </p:sp>
+      <p:sp>
+        <p:nvSpPr>
+          <p:cNvPr id="6" name="Rounded Rectangle 5"/>
+          <p:cNvSpPr/>
+          <p:nvPr/>
+        </p:nvSpPr>
+        <p:spPr>
+          <a:xfrm>
+            <a:off x="3456432" y="1371600"/>
+            <a:ext cx="2542032" cy="4846320"/>
+          </a:xfrm>
+          <a:prstGeom prst="roundRect">
+            <a:avLst/>
+          </a:prstGeom>
+          <a:solidFill>
             <a:srgbClr val="FEF3C7"/>
           </a:solidFill>
           <a:ln w="19050">
@@ -7069,7 +7292,7 @@
               </a:defRPr>
             </a:pPr>
             <a:r>
-              <a:t>第一象限（右上）</a:t>
+              <a:t>右上象限</a:t>
             </a:r>
           </a:p>
           <a:p>
@@ -7081,7 +7304,7 @@
               </a:defRPr>
             </a:pPr>
             <a:r>
-              <a:t>階層制 × 共識型決策</a:t>
+              <a:t>階級 × 由上而下</a:t>
             </a:r>
             <a:br/>
           </a:p>
@@ -7094,7 +7317,7 @@
               </a:defRPr>
             </a:pPr>
             <a:r>
-              <a:t>【日本、德國】</a:t>
+              <a:t>【中國、法國】</a:t>
             </a:r>
           </a:p>
           <a:p>
@@ -7106,7 +7329,7 @@
               </a:defRPr>
             </a:pPr>
             <a:r>
-              <a:t>• 決策機制：根回與稟議制</a:t>
+              <a:t>• 決策機制：指揮官指揮模式</a:t>
             </a:r>
           </a:p>
           <a:p>
@@ -7118,7 +7341,7 @@
               </a:defRPr>
             </a:pPr>
             <a:r>
-              <a:t>• 領導者角色：整合協調者 </a:t>
+              <a:t>• 領導者角色：最高指揮官 </a:t>
             </a:r>
           </a:p>
           <a:p>
@@ -7130,7 +7353,7 @@
               </a:defRPr>
             </a:pPr>
             <a:r>
-              <a:t>• 關鍵動作：大會前私下一對一對齊，由下而上會簽審核。</a:t>
+              <a:t>• 關鍵動作：危機時給予清晰步驟，領導者一肩承擔全部成敗。</a:t>
             </a:r>
           </a:p>
           <a:p>
@@ -7142,134 +7365,7 @@
               </a:defRPr>
             </a:pPr>
             <a:r>
-              <a:t>• 致命地雷：在正式會議強行舉手或當眾表態。</a:t>
-            </a:r>
-          </a:p>
-        </p:txBody>
-      </p:sp>
-      <p:sp>
-        <p:nvSpPr>
-          <p:cNvPr id="6" name="Rounded Rectangle 5"/>
-          <p:cNvSpPr/>
-          <p:nvPr/>
-        </p:nvSpPr>
-        <p:spPr>
-          <a:xfrm>
-            <a:off x="3456432" y="1371600"/>
-            <a:ext cx="2542032" cy="4846320"/>
-          </a:xfrm>
-          <a:prstGeom prst="roundRect">
-            <a:avLst/>
-          </a:prstGeom>
-          <a:solidFill>
-            <a:srgbClr val="EEF2FF"/>
-          </a:solidFill>
-          <a:ln w="19050">
-            <a:solidFill>
-              <a:srgbClr val="4F46E5"/>
-            </a:solidFill>
-          </a:ln>
-        </p:spPr>
-        <p:style>
-          <a:lnRef idx="1">
-            <a:schemeClr val="accent1"/>
-          </a:lnRef>
-          <a:fillRef idx="3">
-            <a:schemeClr val="accent1"/>
-          </a:fillRef>
-          <a:effectRef idx="2">
-            <a:schemeClr val="accent1"/>
-          </a:effectRef>
-          <a:fontRef idx="minor">
-            <a:schemeClr val="lt1"/>
-          </a:fontRef>
-        </p:style>
-        <p:txBody>
-          <a:bodyPr rtlCol="0" anchor="ctr" wrap="square" lIns="182880" tIns="182880" rIns="182880"/>
-          <a:lstStyle/>
-          <a:p>
-            <a:pPr algn="ctr">
-              <a:defRPr sz="1300" b="1">
-                <a:solidFill>
-                  <a:srgbClr val="4F46E5"/>
-                </a:solidFill>
-              </a:defRPr>
-            </a:pPr>
-            <a:r>
-              <a:t>第二象限（左上）</a:t>
-            </a:r>
-          </a:p>
-          <a:p>
-            <a:pPr>
-              <a:defRPr sz="1100" b="1">
-                <a:solidFill>
-                  <a:srgbClr val="1E293B"/>
-                </a:solidFill>
-              </a:defRPr>
-            </a:pPr>
-            <a:r>
-              <a:t>平等主義 × 共識型決策</a:t>
-            </a:r>
-            <a:br/>
-          </a:p>
-          <a:p>
-            <a:pPr>
-              <a:defRPr sz="1000">
-                <a:solidFill>
-                  <a:srgbClr val="475569"/>
-                </a:solidFill>
-              </a:defRPr>
-            </a:pPr>
-            <a:r>
-              <a:t>【丹麥、荷蘭】</a:t>
-            </a:r>
-          </a:p>
-          <a:p>
-            <a:pPr>
-              <a:defRPr sz="1000">
-                <a:solidFill>
-                  <a:srgbClr val="475569"/>
-                </a:solidFill>
-              </a:defRPr>
-            </a:pPr>
-            <a:r>
-              <a:t>• 決策機制：低地共識協商模式</a:t>
-            </a:r>
-          </a:p>
-          <a:p>
-            <a:pPr>
-              <a:defRPr sz="1000">
-                <a:solidFill>
-                  <a:srgbClr val="475569"/>
-                </a:solidFill>
-              </a:defRPr>
-            </a:pPr>
-            <a:r>
-              <a:t>• 領導者角色：中立促進者 </a:t>
-            </a:r>
-          </a:p>
-          <a:p>
-            <a:pPr>
-              <a:defRPr sz="1000">
-                <a:solidFill>
-                  <a:srgbClr val="475569"/>
-                </a:solidFill>
-              </a:defRPr>
-            </a:pPr>
-            <a:r>
-              <a:t>• 關鍵動作：全員公開透明共審，拍板即刻在石碑上不可翻案。</a:t>
-            </a:r>
-          </a:p>
-          <a:p>
-            <a:pPr>
-              <a:defRPr sz="1000">
-                <a:solidFill>
-                  <a:srgbClr val="475569"/>
-                </a:solidFill>
-              </a:defRPr>
-            </a:pPr>
-            <a:r>
-              <a:t>• 致命地雷：私下密室妥協、威權壓迫或隨意翻案。</a:t>
+              <a:t>• 致命地雷：危機時要求基層投票表態，被視為推諉懦弱。</a:t>
             </a:r>
           </a:p>
         </p:txBody>
@@ -7323,7 +7419,7 @@
               </a:defRPr>
             </a:pPr>
             <a:r>
-              <a:t>第三象限（左下）</a:t>
+              <a:t>左下象限</a:t>
             </a:r>
           </a:p>
           <a:p>
@@ -7335,7 +7431,7 @@
               </a:defRPr>
             </a:pPr>
             <a:r>
-              <a:t>平等主義 × 由上而下速決</a:t>
+              <a:t>平等 × 共識</a:t>
             </a:r>
             <a:br/>
           </a:p>
@@ -7348,7 +7444,7 @@
               </a:defRPr>
             </a:pPr>
             <a:r>
-              <a:t>【美國、英國】</a:t>
+              <a:t>【丹麥、荷蘭】</a:t>
             </a:r>
           </a:p>
           <a:p>
@@ -7360,7 +7456,7 @@
               </a:defRPr>
             </a:pPr>
             <a:r>
-              <a:t>• 決策機制：小速決敏捷試錯</a:t>
+              <a:t>• 決策機制：低地共識協商模式</a:t>
             </a:r>
           </a:p>
           <a:p>
@@ -7372,7 +7468,7 @@
               </a:defRPr>
             </a:pPr>
             <a:r>
-              <a:t>• 領導者角色：方向定舵者 </a:t>
+              <a:t>• 領導者角色：中立促進者 </a:t>
             </a:r>
           </a:p>
           <a:p>
@@ -7384,7 +7480,7 @@
               </a:defRPr>
             </a:pPr>
             <a:r>
-              <a:t>• 關鍵動作：鼓勵平等暢所欲言，授權主管速決，後續線上動態修補。</a:t>
+              <a:t>• 關鍵動作：全員公開透明共審，拍板即刻在石碑上不可翻案。</a:t>
             </a:r>
           </a:p>
           <a:p>
@@ -7396,7 +7492,7 @@
               </a:defRPr>
             </a:pPr>
             <a:r>
-              <a:t>• 致命地雷：耗費數週追求全員共識，錯失市場先機。</a:t>
+              <a:t>• 致命地雷：私下密室妥協、威權壓迫或隨意翻案。</a:t>
             </a:r>
           </a:p>
         </p:txBody>
@@ -7450,7 +7546,7 @@
               </a:defRPr>
             </a:pPr>
             <a:r>
-              <a:t>第四象限（右下）</a:t>
+              <a:t>右下象限</a:t>
             </a:r>
           </a:p>
           <a:p>
@@ -7462,7 +7558,7 @@
               </a:defRPr>
             </a:pPr>
             <a:r>
-              <a:t>階層制 × 由上而下速決</a:t>
+              <a:t>階級 × 共識</a:t>
             </a:r>
             <a:br/>
           </a:p>
@@ -7475,7 +7571,7 @@
               </a:defRPr>
             </a:pPr>
             <a:r>
-              <a:t>【中國、法國】</a:t>
+              <a:t>【德國、日本】</a:t>
             </a:r>
           </a:p>
           <a:p>
@@ -7487,7 +7583,7 @@
               </a:defRPr>
             </a:pPr>
             <a:r>
-              <a:t>• 決策機制：指揮官指揮模式</a:t>
+              <a:t>• 決策機制：根回與稟議制</a:t>
             </a:r>
           </a:p>
           <a:p>
@@ -7499,7 +7595,7 @@
               </a:defRPr>
             </a:pPr>
             <a:r>
-              <a:t>• 領導者角色：最高指揮官 </a:t>
+              <a:t>• 領導者角色：整合協調者 </a:t>
             </a:r>
           </a:p>
           <a:p>
@@ -7511,7 +7607,7 @@
               </a:defRPr>
             </a:pPr>
             <a:r>
-              <a:t>• 關鍵動作：危機時給予清晰步驟，領導者一肩承擔全部成敗。</a:t>
+              <a:t>• 關鍵動作：大會前私下一對一對齊，由下而上會簽審核。</a:t>
             </a:r>
           </a:p>
           <a:p>
@@ -7523,7 +7619,7 @@
               </a:defRPr>
             </a:pPr>
             <a:r>
-              <a:t>• 致命地雷：危機時要求基層投票表態，被視為推諉懦弱。</a:t>
+              <a:t>• 致命地雷：在正式會議強行舉手或當眾表態。</a:t>
             </a:r>
           </a:p>
         </p:txBody>
@@ -9206,19 +9302,31 @@
               </a:defRPr>
             </a:pPr>
             <a:r>
-              <a:t>第二象限（左上）</a:t>
+              <a:t>左上象限</a:t>
             </a:r>
           </a:p>
           <a:p>
             <a:pPr algn="ctr">
-              <a:defRPr sz="900">
+              <a:defRPr sz="850">
                 <a:solidFill>
                   <a:srgbClr val="475569"/>
                 </a:solidFill>
               </a:defRPr>
             </a:pPr>
             <a:r>
-              <a:t>共識決策 × 平等主義</a:t>
+              <a:t>平等 × 由上而下</a:t>
+            </a:r>
+          </a:p>
+          <a:p>
+            <a:pPr algn="ctr">
+              <a:defRPr sz="850">
+                <a:solidFill>
+                  <a:srgbClr val="475569"/>
+                </a:solidFill>
+              </a:defRPr>
+            </a:pPr>
+            <a:r>
+              <a:t>（美國、英國）</a:t>
             </a:r>
           </a:p>
         </p:txBody>
@@ -9272,19 +9380,31 @@
               </a:defRPr>
             </a:pPr>
             <a:r>
-              <a:t>第一象限（右上）</a:t>
+              <a:t>右上象限</a:t>
             </a:r>
           </a:p>
           <a:p>
             <a:pPr algn="ctr">
-              <a:defRPr sz="900">
+              <a:defRPr sz="850">
                 <a:solidFill>
                   <a:srgbClr val="475569"/>
                 </a:solidFill>
               </a:defRPr>
             </a:pPr>
             <a:r>
-              <a:t>共識決策 × 階層制</a:t>
+              <a:t>階級 × 由上而下</a:t>
+            </a:r>
+          </a:p>
+          <a:p>
+            <a:pPr algn="ctr">
+              <a:defRPr sz="850">
+                <a:solidFill>
+                  <a:srgbClr val="475569"/>
+                </a:solidFill>
+              </a:defRPr>
+            </a:pPr>
+            <a:r>
+              <a:t>（中國、法國）</a:t>
             </a:r>
           </a:p>
         </p:txBody>
@@ -9338,19 +9458,31 @@
               </a:defRPr>
             </a:pPr>
             <a:r>
-              <a:t>第三象限（左下）</a:t>
+              <a:t>左下象限</a:t>
             </a:r>
           </a:p>
           <a:p>
             <a:pPr algn="ctr">
-              <a:defRPr sz="900">
+              <a:defRPr sz="850">
                 <a:solidFill>
                   <a:srgbClr val="475569"/>
                 </a:solidFill>
               </a:defRPr>
             </a:pPr>
             <a:r>
-              <a:t>由上而下 × 平等主義</a:t>
+              <a:t>平等 × 共識</a:t>
+            </a:r>
+          </a:p>
+          <a:p>
+            <a:pPr algn="ctr">
+              <a:defRPr sz="850">
+                <a:solidFill>
+                  <a:srgbClr val="475569"/>
+                </a:solidFill>
+              </a:defRPr>
+            </a:pPr>
+            <a:r>
+              <a:t>（丹麥、荷蘭）</a:t>
             </a:r>
           </a:p>
         </p:txBody>
@@ -9404,19 +9536,31 @@
               </a:defRPr>
             </a:pPr>
             <a:r>
-              <a:t>第四象限（右下）</a:t>
+              <a:t>右下象限</a:t>
             </a:r>
           </a:p>
           <a:p>
             <a:pPr algn="ctr">
-              <a:defRPr sz="900">
+              <a:defRPr sz="850">
                 <a:solidFill>
                   <a:srgbClr val="475569"/>
                 </a:solidFill>
               </a:defRPr>
             </a:pPr>
             <a:r>
-              <a:t>由上而下 × 階層制</a:t>
+              <a:t>階級 × 共識</a:t>
+            </a:r>
+          </a:p>
+          <a:p>
+            <a:pPr algn="ctr">
+              <a:defRPr sz="850">
+                <a:solidFill>
+                  <a:srgbClr val="475569"/>
+                </a:solidFill>
+              </a:defRPr>
+            </a:pPr>
+            <a:r>
+              <a:t>（德國、日本）</a:t>
             </a:r>
           </a:p>
         </p:txBody>
@@ -9430,6 +9574,72 @@
         <p:spPr>
           <a:xfrm>
             <a:off x="5943600" y="1417320"/>
+            <a:ext cx="5486400" cy="1078992"/>
+          </a:xfrm>
+          <a:prstGeom prst="roundRect">
+            <a:avLst/>
+          </a:prstGeom>
+          <a:solidFill>
+            <a:srgbClr val="EEF2FF"/>
+          </a:solidFill>
+          <a:ln w="19050">
+            <a:solidFill>
+              <a:srgbClr val="4F46E5"/>
+            </a:solidFill>
+          </a:ln>
+        </p:spPr>
+        <p:style>
+          <a:lnRef idx="1">
+            <a:schemeClr val="accent1"/>
+          </a:lnRef>
+          <a:fillRef idx="3">
+            <a:schemeClr val="accent1"/>
+          </a:fillRef>
+          <a:effectRef idx="2">
+            <a:schemeClr val="accent1"/>
+          </a:effectRef>
+          <a:fontRef idx="minor">
+            <a:schemeClr val="lt1"/>
+          </a:fontRef>
+        </p:style>
+        <p:txBody>
+          <a:bodyPr rtlCol="0" anchor="ctr" wrap="square" lIns="164592" tIns="164592" rIns="164592"/>
+          <a:lstStyle/>
+          <a:p>
+            <a:pPr algn="ctr">
+              <a:defRPr sz="1200" b="1">
+                <a:solidFill>
+                  <a:srgbClr val="1E293B"/>
+                </a:solidFill>
+              </a:defRPr>
+            </a:pPr>
+            <a:r>
+              <a:t>左上象限：平等 × 由上而下</a:t>
+            </a:r>
+          </a:p>
+          <a:p>
+            <a:pPr>
+              <a:defRPr sz="1000">
+                <a:solidFill>
+                  <a:srgbClr val="475569"/>
+                </a:solidFill>
+              </a:defRPr>
+            </a:pPr>
+            <a:r>
+              <a:t>【美國、英國】扁平極客文化，鼓勵直抒己見甚至挑戰主管；但決策採「小速決」模式，由主管快速拍板，先試跑再動態修補。</a:t>
+            </a:r>
+          </a:p>
+        </p:txBody>
+      </p:sp>
+      <p:sp>
+        <p:nvSpPr>
+          <p:cNvPr id="10" name="Rounded Rectangle 9"/>
+          <p:cNvSpPr/>
+          <p:nvPr/>
+        </p:nvSpPr>
+        <p:spPr>
+          <a:xfrm>
+            <a:off x="5943600" y="2606040"/>
             <a:ext cx="5486400" cy="1078992"/>
           </a:xfrm>
           <a:prstGeom prst="roundRect">
@@ -9470,7 +9680,7 @@
               </a:defRPr>
             </a:pPr>
             <a:r>
-              <a:t>第一象限（右上）：共識型決策 × 階層制</a:t>
+              <a:t>右上象限：階級 × 由上而下</a:t>
             </a:r>
           </a:p>
           <a:p>
@@ -9482,73 +9692,7 @@
               </a:defRPr>
             </a:pPr>
             <a:r>
-              <a:t>【日本、德國】嚴明職級尊重與全員共識並存。正式會議僅為形式用印，真正的決策必須在會前依職級序列由下而上完成「會前私下摸底（根回）」。</a:t>
-            </a:r>
-          </a:p>
-        </p:txBody>
-      </p:sp>
-      <p:sp>
-        <p:nvSpPr>
-          <p:cNvPr id="10" name="Rounded Rectangle 9"/>
-          <p:cNvSpPr/>
-          <p:nvPr/>
-        </p:nvSpPr>
-        <p:spPr>
-          <a:xfrm>
-            <a:off x="5943600" y="2606040"/>
-            <a:ext cx="5486400" cy="1078992"/>
-          </a:xfrm>
-          <a:prstGeom prst="roundRect">
-            <a:avLst/>
-          </a:prstGeom>
-          <a:solidFill>
-            <a:srgbClr val="EEF2FF"/>
-          </a:solidFill>
-          <a:ln w="19050">
-            <a:solidFill>
-              <a:srgbClr val="4F46E5"/>
-            </a:solidFill>
-          </a:ln>
-        </p:spPr>
-        <p:style>
-          <a:lnRef idx="1">
-            <a:schemeClr val="accent1"/>
-          </a:lnRef>
-          <a:fillRef idx="3">
-            <a:schemeClr val="accent1"/>
-          </a:fillRef>
-          <a:effectRef idx="2">
-            <a:schemeClr val="accent1"/>
-          </a:effectRef>
-          <a:fontRef idx="minor">
-            <a:schemeClr val="lt1"/>
-          </a:fontRef>
-        </p:style>
-        <p:txBody>
-          <a:bodyPr rtlCol="0" anchor="ctr" wrap="square" lIns="164592" tIns="164592" rIns="164592"/>
-          <a:lstStyle/>
-          <a:p>
-            <a:pPr algn="ctr">
-              <a:defRPr sz="1200" b="1">
-                <a:solidFill>
-                  <a:srgbClr val="1E293B"/>
-                </a:solidFill>
-              </a:defRPr>
-            </a:pPr>
-            <a:r>
-              <a:t>第二象限（左上）：共識型決策 × 平等主義</a:t>
-            </a:r>
-          </a:p>
-          <a:p>
-            <a:pPr>
-              <a:defRPr sz="1000">
-                <a:solidFill>
-                  <a:srgbClr val="475569"/>
-                </a:solidFill>
-              </a:defRPr>
-            </a:pPr>
-            <a:r>
-              <a:t>【丹麥、荷蘭】基層與主管平起平坐，人人皆有一票否決權。領導者為「促進者」，追求刻在石碑上的神聖大承諾。</a:t>
+              <a:t>【中國、法國】強調最高主管威權指揮（最高指揮官模式）。危機時刻基層渴望明確指令，領導者必須一肩扛起成敗責任。</a:t>
             </a:r>
           </a:p>
         </p:txBody>
@@ -9602,7 +9746,7 @@
               </a:defRPr>
             </a:pPr>
             <a:r>
-              <a:t>第三象限（左下）：由上而下速決 × 平等主義</a:t>
+              <a:t>左下象限：平等 × 共識</a:t>
             </a:r>
           </a:p>
           <a:p>
@@ -9614,7 +9758,7 @@
               </a:defRPr>
             </a:pPr>
             <a:r>
-              <a:t>【美國、英國】扁平極客文化，鼓勵直抒己見甚至挑戰主管；但決策採「小速決」模式，先試跑、後續動態修補。</a:t>
+              <a:t>【丹麥、荷蘭】基層與主管平起平坐，人人皆有一票否決權。領導者為「促進者」，追求刻在石碑上的神聖大承諾。</a:t>
             </a:r>
           </a:p>
         </p:txBody>
@@ -9668,7 +9812,7 @@
               </a:defRPr>
             </a:pPr>
             <a:r>
-              <a:t>第四象限（右下）：由上而下速決 × 階層制</a:t>
+              <a:t>右下象限：階級 × 共識</a:t>
             </a:r>
           </a:p>
           <a:p>
@@ -9680,7 +9824,7 @@
               </a:defRPr>
             </a:pPr>
             <a:r>
-              <a:t>【中國、法國】強調最高主管威權指揮（最高指揮官模式）。危機時刻基層渴望明確指令，領導者必須一肩扛起成敗責任。</a:t>
+              <a:t>【德國、日本】嚴明職級尊重與全員共識並存。正式會議僅為形式用印，真正的決策必須在會前依職級序列由下而上完成「會前私下摸底（根回）」。</a:t>
             </a:r>
           </a:p>
         </p:txBody>
@@ -10837,7 +10981,7 @@
               </a:defRPr>
             </a:pPr>
             <a:r>
-              <a:t>案例一 答案揭曉 · 第一象限（右上：橫軸 78，縱軸 82）</a:t>
+              <a:t>案例一 答案揭曉 · 右下象限（右下：橫軸 78，縱軸 18）</a:t>
             </a:r>
           </a:p>
         </p:txBody>
@@ -10889,7 +11033,7 @@
               </a:defRPr>
             </a:pPr>
             <a:r>
-              <a:t>正確答案（右上）</a:t>
+              <a:t>正確答案（右下）</a:t>
             </a:r>
           </a:p>
           <a:p>
@@ -10901,7 +11045,7 @@
               </a:defRPr>
             </a:pPr>
             <a:r>
-              <a:t>第一象限</a:t>
+              <a:t>右下象限</a:t>
             </a:r>
           </a:p>
           <a:p>
@@ -10913,7 +11057,7 @@
               </a:defRPr>
             </a:pPr>
             <a:r>
-              <a:t>階層制 × 共識型決策</a:t>
+              <a:t>階級 × 共識</a:t>
             </a:r>
           </a:p>
           <a:p>
@@ -10928,7 +11072,7 @@
               </a:defRPr>
             </a:pPr>
             <a:r>
-              <a:t>【代表國家：日本、德國】</a:t>
+              <a:t>【代表國家：德國、日本】</a:t>
             </a:r>
           </a:p>
           <a:p>
@@ -10943,7 +11087,7 @@
               </a:defRPr>
             </a:pPr>
             <a:r>
-              <a:t>🎯 靶心座標：(78, 82)</a:t>
+              <a:t>🎯 靶心座標：(78, 18)</a:t>
             </a:r>
           </a:p>
           <a:p>
@@ -11012,19 +11156,31 @@
               </a:defRPr>
             </a:pPr>
             <a:r>
-              <a:t>第二象限（左上）</a:t>
+              <a:t>左上象限</a:t>
             </a:r>
           </a:p>
           <a:p>
             <a:pPr algn="ctr">
-              <a:defRPr sz="900">
+              <a:defRPr sz="850">
                 <a:solidFill>
                   <a:srgbClr val="475569"/>
                 </a:solidFill>
               </a:defRPr>
             </a:pPr>
             <a:r>
-              <a:t>共識決策 × 平等主義</a:t>
+              <a:t>平等 × 由上而下</a:t>
+            </a:r>
+          </a:p>
+          <a:p>
+            <a:pPr algn="ctr">
+              <a:defRPr sz="850">
+                <a:solidFill>
+                  <a:srgbClr val="475569"/>
+                </a:solidFill>
+              </a:defRPr>
+            </a:pPr>
+            <a:r>
+              <a:t>（美國、英國）</a:t>
             </a:r>
           </a:p>
         </p:txBody>
@@ -11038,72 +11194,6 @@
         <p:spPr>
           <a:xfrm>
             <a:off x="2697480" y="4114800"/>
-            <a:ext cx="1051560" cy="1051560"/>
-          </a:xfrm>
-          <a:prstGeom prst="roundRect">
-            <a:avLst/>
-          </a:prstGeom>
-          <a:solidFill>
-            <a:srgbClr val="FEF3C7"/>
-          </a:solidFill>
-          <a:ln w="12700">
-            <a:solidFill>
-              <a:srgbClr val="E2E8F0"/>
-            </a:solidFill>
-          </a:ln>
-        </p:spPr>
-        <p:style>
-          <a:lnRef idx="1">
-            <a:schemeClr val="accent1"/>
-          </a:lnRef>
-          <a:fillRef idx="3">
-            <a:schemeClr val="accent1"/>
-          </a:fillRef>
-          <a:effectRef idx="2">
-            <a:schemeClr val="accent1"/>
-          </a:effectRef>
-          <a:fontRef idx="minor">
-            <a:schemeClr val="lt1"/>
-          </a:fontRef>
-        </p:style>
-        <p:txBody>
-          <a:bodyPr rtlCol="0" anchor="ctr" wrap="square"/>
-          <a:lstStyle/>
-          <a:p>
-            <a:pPr algn="ctr">
-              <a:defRPr sz="1000" b="1">
-                <a:solidFill>
-                  <a:srgbClr val="1E293B"/>
-                </a:solidFill>
-              </a:defRPr>
-            </a:pPr>
-            <a:r>
-              <a:t>第一象限（右上）</a:t>
-            </a:r>
-          </a:p>
-          <a:p>
-            <a:pPr algn="ctr">
-              <a:defRPr sz="900">
-                <a:solidFill>
-                  <a:srgbClr val="475569"/>
-                </a:solidFill>
-              </a:defRPr>
-            </a:pPr>
-            <a:r>
-              <a:t>共識決策 × 階層制</a:t>
-            </a:r>
-          </a:p>
-        </p:txBody>
-      </p:sp>
-      <p:sp>
-        <p:nvSpPr>
-          <p:cNvPr id="8" name="Rounded Rectangle 7"/>
-          <p:cNvSpPr/>
-          <p:nvPr/>
-        </p:nvSpPr>
-        <p:spPr>
-          <a:xfrm>
-            <a:off x="1645920" y="5166360"/>
             <a:ext cx="1051560" cy="1051560"/>
           </a:xfrm>
           <a:prstGeom prst="roundRect">
@@ -11144,32 +11234,44 @@
               </a:defRPr>
             </a:pPr>
             <a:r>
-              <a:t>第三象限（左下）</a:t>
+              <a:t>右上象限</a:t>
             </a:r>
           </a:p>
           <a:p>
             <a:pPr algn="ctr">
-              <a:defRPr sz="900">
+              <a:defRPr sz="850">
                 <a:solidFill>
                   <a:srgbClr val="475569"/>
                 </a:solidFill>
               </a:defRPr>
             </a:pPr>
             <a:r>
-              <a:t>由上而下 × 平等主義</a:t>
-            </a:r>
-          </a:p>
-        </p:txBody>
-      </p:sp>
-      <p:sp>
-        <p:nvSpPr>
-          <p:cNvPr id="9" name="Rounded Rectangle 8"/>
+              <a:t>階級 × 由上而下</a:t>
+            </a:r>
+          </a:p>
+          <a:p>
+            <a:pPr algn="ctr">
+              <a:defRPr sz="850">
+                <a:solidFill>
+                  <a:srgbClr val="475569"/>
+                </a:solidFill>
+              </a:defRPr>
+            </a:pPr>
+            <a:r>
+              <a:t>（中國、法國）</a:t>
+            </a:r>
+          </a:p>
+        </p:txBody>
+      </p:sp>
+      <p:sp>
+        <p:nvSpPr>
+          <p:cNvPr id="8" name="Rounded Rectangle 7"/>
           <p:cNvSpPr/>
           <p:nvPr/>
         </p:nvSpPr>
         <p:spPr>
           <a:xfrm>
-            <a:off x="2697480" y="5166360"/>
+            <a:off x="1645920" y="5166360"/>
             <a:ext cx="1051560" cy="1051560"/>
           </a:xfrm>
           <a:prstGeom prst="roundRect">
@@ -11210,19 +11312,109 @@
               </a:defRPr>
             </a:pPr>
             <a:r>
-              <a:t>第四象限（右下）</a:t>
+              <a:t>左下象限</a:t>
             </a:r>
           </a:p>
           <a:p>
             <a:pPr algn="ctr">
-              <a:defRPr sz="900">
+              <a:defRPr sz="850">
                 <a:solidFill>
                   <a:srgbClr val="475569"/>
                 </a:solidFill>
               </a:defRPr>
             </a:pPr>
             <a:r>
-              <a:t>由上而下 × 階層制</a:t>
+              <a:t>平等 × 共識</a:t>
+            </a:r>
+          </a:p>
+          <a:p>
+            <a:pPr algn="ctr">
+              <a:defRPr sz="850">
+                <a:solidFill>
+                  <a:srgbClr val="475569"/>
+                </a:solidFill>
+              </a:defRPr>
+            </a:pPr>
+            <a:r>
+              <a:t>（丹麥、荷蘭）</a:t>
+            </a:r>
+          </a:p>
+        </p:txBody>
+      </p:sp>
+      <p:sp>
+        <p:nvSpPr>
+          <p:cNvPr id="9" name="Rounded Rectangle 8"/>
+          <p:cNvSpPr/>
+          <p:nvPr/>
+        </p:nvSpPr>
+        <p:spPr>
+          <a:xfrm>
+            <a:off x="2697480" y="5166360"/>
+            <a:ext cx="1051560" cy="1051560"/>
+          </a:xfrm>
+          <a:prstGeom prst="roundRect">
+            <a:avLst/>
+          </a:prstGeom>
+          <a:solidFill>
+            <a:srgbClr val="E0F2FE"/>
+          </a:solidFill>
+          <a:ln w="12700">
+            <a:solidFill>
+              <a:srgbClr val="E2E8F0"/>
+            </a:solidFill>
+          </a:ln>
+        </p:spPr>
+        <p:style>
+          <a:lnRef idx="1">
+            <a:schemeClr val="accent1"/>
+          </a:lnRef>
+          <a:fillRef idx="3">
+            <a:schemeClr val="accent1"/>
+          </a:fillRef>
+          <a:effectRef idx="2">
+            <a:schemeClr val="accent1"/>
+          </a:effectRef>
+          <a:fontRef idx="minor">
+            <a:schemeClr val="lt1"/>
+          </a:fontRef>
+        </p:style>
+        <p:txBody>
+          <a:bodyPr rtlCol="0" anchor="ctr" wrap="square"/>
+          <a:lstStyle/>
+          <a:p>
+            <a:pPr algn="ctr">
+              <a:defRPr sz="1000" b="1">
+                <a:solidFill>
+                  <a:srgbClr val="1E293B"/>
+                </a:solidFill>
+              </a:defRPr>
+            </a:pPr>
+            <a:r>
+              <a:t>右下象限</a:t>
+            </a:r>
+          </a:p>
+          <a:p>
+            <a:pPr algn="ctr">
+              <a:defRPr sz="850">
+                <a:solidFill>
+                  <a:srgbClr val="475569"/>
+                </a:solidFill>
+              </a:defRPr>
+            </a:pPr>
+            <a:r>
+              <a:t>階級 × 共識</a:t>
+            </a:r>
+          </a:p>
+          <a:p>
+            <a:pPr algn="ctr">
+              <a:defRPr sz="850">
+                <a:solidFill>
+                  <a:srgbClr val="475569"/>
+                </a:solidFill>
+              </a:defRPr>
+            </a:pPr>
+            <a:r>
+              <a:t>（德國、日本）</a:t>
             </a:r>
           </a:p>
         </p:txBody>
@@ -11235,7 +11427,7 @@
         </p:nvSpPr>
         <p:spPr>
           <a:xfrm>
-            <a:off x="3176625" y="4383633"/>
+            <a:off x="3176625" y="5729630"/>
             <a:ext cx="219456" cy="219456"/>
           </a:xfrm>
           <a:prstGeom prst="ellipse">
@@ -11336,7 +11528,7 @@
               </a:defRPr>
             </a:pPr>
             <a:r>
-              <a:t>代表國家：日本、德國</a:t>
+              <a:t>代表國家：德國、日本</a:t>
             </a:r>
           </a:p>
           <a:p>
@@ -11366,7 +11558,7 @@
               </a:defRPr>
             </a:pPr>
             <a:r>
-              <a:t>日本根回與稟議模式，兼具嚴明的職級尊卑與全員深度共識。</a:t>
+              <a:t>兼具嚴明的職級尊卑與全員深度共識，重視循序漸進的組織倫理與事前校準。</a:t>
             </a:r>
           </a:p>
           <a:p>
@@ -11983,7 +12175,7 @@
               </a:defRPr>
             </a:pPr>
             <a:r>
-              <a:t>案例二 答案揭曉 · 第四象限（右下：橫軸 84，縱軸 18）</a:t>
+              <a:t>案例二 答案揭曉 · 右上象限（右上：橫軸 84，縱軸 82）</a:t>
             </a:r>
           </a:p>
         </p:txBody>
@@ -12035,7 +12227,7 @@
               </a:defRPr>
             </a:pPr>
             <a:r>
-              <a:t>正確答案（右下）</a:t>
+              <a:t>正確答案（右上）</a:t>
             </a:r>
           </a:p>
           <a:p>
@@ -12047,7 +12239,7 @@
               </a:defRPr>
             </a:pPr>
             <a:r>
-              <a:t>第四象限</a:t>
+              <a:t>右上象限</a:t>
             </a:r>
           </a:p>
           <a:p>
@@ -12059,7 +12251,7 @@
               </a:defRPr>
             </a:pPr>
             <a:r>
-              <a:t>階層制 × 由上而下速決</a:t>
+              <a:t>階級 × 由上而下</a:t>
             </a:r>
           </a:p>
           <a:p>
@@ -12089,7 +12281,7 @@
               </a:defRPr>
             </a:pPr>
             <a:r>
-              <a:t>🎯 靶心座標：(84, 18)</a:t>
+              <a:t>🎯 靶心座標：(84, 82)</a:t>
             </a:r>
           </a:p>
           <a:p>
@@ -12158,19 +12350,31 @@
               </a:defRPr>
             </a:pPr>
             <a:r>
-              <a:t>第二象限（左上）</a:t>
+              <a:t>左上象限</a:t>
             </a:r>
           </a:p>
           <a:p>
             <a:pPr algn="ctr">
-              <a:defRPr sz="900">
+              <a:defRPr sz="850">
                 <a:solidFill>
                   <a:srgbClr val="475569"/>
                 </a:solidFill>
               </a:defRPr>
             </a:pPr>
             <a:r>
-              <a:t>共識決策 × 平等主義</a:t>
+              <a:t>平等 × 由上而下</a:t>
+            </a:r>
+          </a:p>
+          <a:p>
+            <a:pPr algn="ctr">
+              <a:defRPr sz="850">
+                <a:solidFill>
+                  <a:srgbClr val="475569"/>
+                </a:solidFill>
+              </a:defRPr>
+            </a:pPr>
+            <a:r>
+              <a:t>（美國、英國）</a:t>
             </a:r>
           </a:p>
         </p:txBody>
@@ -12184,6 +12388,84 @@
         <p:spPr>
           <a:xfrm>
             <a:off x="2697480" y="4114800"/>
+            <a:ext cx="1051560" cy="1051560"/>
+          </a:xfrm>
+          <a:prstGeom prst="roundRect">
+            <a:avLst/>
+          </a:prstGeom>
+          <a:solidFill>
+            <a:srgbClr val="FEF3C7"/>
+          </a:solidFill>
+          <a:ln w="12700">
+            <a:solidFill>
+              <a:srgbClr val="E2E8F0"/>
+            </a:solidFill>
+          </a:ln>
+        </p:spPr>
+        <p:style>
+          <a:lnRef idx="1">
+            <a:schemeClr val="accent1"/>
+          </a:lnRef>
+          <a:fillRef idx="3">
+            <a:schemeClr val="accent1"/>
+          </a:fillRef>
+          <a:effectRef idx="2">
+            <a:schemeClr val="accent1"/>
+          </a:effectRef>
+          <a:fontRef idx="minor">
+            <a:schemeClr val="lt1"/>
+          </a:fontRef>
+        </p:style>
+        <p:txBody>
+          <a:bodyPr rtlCol="0" anchor="ctr" wrap="square"/>
+          <a:lstStyle/>
+          <a:p>
+            <a:pPr algn="ctr">
+              <a:defRPr sz="1000" b="1">
+                <a:solidFill>
+                  <a:srgbClr val="1E293B"/>
+                </a:solidFill>
+              </a:defRPr>
+            </a:pPr>
+            <a:r>
+              <a:t>右上象限</a:t>
+            </a:r>
+          </a:p>
+          <a:p>
+            <a:pPr algn="ctr">
+              <a:defRPr sz="850">
+                <a:solidFill>
+                  <a:srgbClr val="475569"/>
+                </a:solidFill>
+              </a:defRPr>
+            </a:pPr>
+            <a:r>
+              <a:t>階級 × 由上而下</a:t>
+            </a:r>
+          </a:p>
+          <a:p>
+            <a:pPr algn="ctr">
+              <a:defRPr sz="850">
+                <a:solidFill>
+                  <a:srgbClr val="475569"/>
+                </a:solidFill>
+              </a:defRPr>
+            </a:pPr>
+            <a:r>
+              <a:t>（中國、法國）</a:t>
+            </a:r>
+          </a:p>
+        </p:txBody>
+      </p:sp>
+      <p:sp>
+        <p:nvSpPr>
+          <p:cNvPr id="8" name="Rounded Rectangle 7"/>
+          <p:cNvSpPr/>
+          <p:nvPr/>
+        </p:nvSpPr>
+        <p:spPr>
+          <a:xfrm>
+            <a:off x="1645920" y="5166360"/>
             <a:ext cx="1051560" cy="1051560"/>
           </a:xfrm>
           <a:prstGeom prst="roundRect">
@@ -12224,32 +12506,44 @@
               </a:defRPr>
             </a:pPr>
             <a:r>
-              <a:t>第一象限（右上）</a:t>
+              <a:t>左下象限</a:t>
             </a:r>
           </a:p>
           <a:p>
             <a:pPr algn="ctr">
-              <a:defRPr sz="900">
+              <a:defRPr sz="850">
                 <a:solidFill>
                   <a:srgbClr val="475569"/>
                 </a:solidFill>
               </a:defRPr>
             </a:pPr>
             <a:r>
-              <a:t>共識決策 × 階層制</a:t>
-            </a:r>
-          </a:p>
-        </p:txBody>
-      </p:sp>
-      <p:sp>
-        <p:nvSpPr>
-          <p:cNvPr id="8" name="Rounded Rectangle 7"/>
+              <a:t>平等 × 共識</a:t>
+            </a:r>
+          </a:p>
+          <a:p>
+            <a:pPr algn="ctr">
+              <a:defRPr sz="850">
+                <a:solidFill>
+                  <a:srgbClr val="475569"/>
+                </a:solidFill>
+              </a:defRPr>
+            </a:pPr>
+            <a:r>
+              <a:t>（丹麥、荷蘭）</a:t>
+            </a:r>
+          </a:p>
+        </p:txBody>
+      </p:sp>
+      <p:sp>
+        <p:nvSpPr>
+          <p:cNvPr id="9" name="Rounded Rectangle 8"/>
           <p:cNvSpPr/>
           <p:nvPr/>
         </p:nvSpPr>
         <p:spPr>
           <a:xfrm>
-            <a:off x="1645920" y="5166360"/>
+            <a:off x="2697480" y="5166360"/>
             <a:ext cx="1051560" cy="1051560"/>
           </a:xfrm>
           <a:prstGeom prst="roundRect">
@@ -12290,85 +12584,31 @@
               </a:defRPr>
             </a:pPr>
             <a:r>
-              <a:t>第三象限（左下）</a:t>
+              <a:t>右下象限</a:t>
             </a:r>
           </a:p>
           <a:p>
             <a:pPr algn="ctr">
-              <a:defRPr sz="900">
+              <a:defRPr sz="850">
                 <a:solidFill>
                   <a:srgbClr val="475569"/>
                 </a:solidFill>
               </a:defRPr>
             </a:pPr>
             <a:r>
-              <a:t>由上而下 × 平等主義</a:t>
-            </a:r>
-          </a:p>
-        </p:txBody>
-      </p:sp>
-      <p:sp>
-        <p:nvSpPr>
-          <p:cNvPr id="9" name="Rounded Rectangle 8"/>
-          <p:cNvSpPr/>
-          <p:nvPr/>
-        </p:nvSpPr>
-        <p:spPr>
-          <a:xfrm>
-            <a:off x="2697480" y="5166360"/>
-            <a:ext cx="1051560" cy="1051560"/>
-          </a:xfrm>
-          <a:prstGeom prst="roundRect">
-            <a:avLst/>
-          </a:prstGeom>
-          <a:solidFill>
-            <a:srgbClr val="E0F2FE"/>
-          </a:solidFill>
-          <a:ln w="12700">
-            <a:solidFill>
-              <a:srgbClr val="E2E8F0"/>
-            </a:solidFill>
-          </a:ln>
-        </p:spPr>
-        <p:style>
-          <a:lnRef idx="1">
-            <a:schemeClr val="accent1"/>
-          </a:lnRef>
-          <a:fillRef idx="3">
-            <a:schemeClr val="accent1"/>
-          </a:fillRef>
-          <a:effectRef idx="2">
-            <a:schemeClr val="accent1"/>
-          </a:effectRef>
-          <a:fontRef idx="minor">
-            <a:schemeClr val="lt1"/>
-          </a:fontRef>
-        </p:style>
-        <p:txBody>
-          <a:bodyPr rtlCol="0" anchor="ctr" wrap="square"/>
-          <a:lstStyle/>
+              <a:t>階級 × 共識</a:t>
+            </a:r>
+          </a:p>
           <a:p>
             <a:pPr algn="ctr">
-              <a:defRPr sz="1000" b="1">
-                <a:solidFill>
-                  <a:srgbClr val="1E293B"/>
-                </a:solidFill>
-              </a:defRPr>
-            </a:pPr>
-            <a:r>
-              <a:t>第四象限（右下）</a:t>
-            </a:r>
-          </a:p>
-          <a:p>
-            <a:pPr algn="ctr">
-              <a:defRPr sz="900">
+              <a:defRPr sz="850">
                 <a:solidFill>
                   <a:srgbClr val="475569"/>
                 </a:solidFill>
               </a:defRPr>
             </a:pPr>
             <a:r>
-              <a:t>由上而下 × 階層制</a:t>
+              <a:t>（德國、日本）</a:t>
             </a:r>
           </a:p>
         </p:txBody>
@@ -12381,7 +12621,7 @@
         </p:nvSpPr>
         <p:spPr>
           <a:xfrm>
-            <a:off x="3302812" y="5729630"/>
+            <a:off x="3302812" y="4383633"/>
             <a:ext cx="219456" cy="219456"/>
           </a:xfrm>
           <a:prstGeom prst="ellipse">

</xml_diff>

<commit_message>
feat: add concise question clue bullets across host, participant, and backup slides
</commit_message>
<xml_diff>
--- a/誰是文化王_備案簡報_Who_Is_Culture_King.pptx
+++ b/誰是文化王_備案簡報_Who_Is_Culture_King.pptx
@@ -5670,11 +5670,11 @@
           </a:fontRef>
         </p:style>
         <p:txBody>
-          <a:bodyPr rtlCol="0" anchor="ctr" wrap="square" lIns="365760" rIns="365760" tIns="365760"/>
+          <a:bodyPr rtlCol="0" anchor="ctr" wrap="square" lIns="365760" rIns="365760" tIns="274320"/>
           <a:lstStyle/>
           <a:p>
             <a:pPr algn="ctr">
-              <a:defRPr sz="2000" b="1">
+              <a:defRPr sz="1800" b="1">
                 <a:solidFill>
                   <a:srgbClr val="1E293B"/>
                 </a:solidFill>
@@ -5687,9 +5687,9 @@
           <a:p>
             <a:pPr>
               <a:spcBef>
-                <a:spcPts val="400"/>
+                <a:spcPts val="300"/>
               </a:spcBef>
-              <a:defRPr sz="1500" b="1">
+              <a:defRPr sz="1350" b="1">
                 <a:solidFill>
                   <a:srgbClr val="0284C7"/>
                 </a:solidFill>
@@ -5702,11 +5702,41 @@
           <a:p>
             <a:pPr>
               <a:spcBef>
-                <a:spcPts val="1600"/>
+                <a:spcPts val="900"/>
               </a:spcBef>
-              <a:defRPr sz="1700" b="1">
-                <a:solidFill>
-                  <a:srgbClr val="1E293B"/>
+              <a:defRPr sz="1400" b="1">
+                <a:solidFill>
+                  <a:srgbClr val="4F46E5"/>
+                </a:solidFill>
+              </a:defRPr>
+            </a:pPr>
+            <a:r>
+              <a:t>題目線索：</a:t>
+            </a:r>
+          </a:p>
+          <a:p>
+            <a:pPr>
+              <a:lnSpc>
+                <a:spcPct val="125000"/>
+              </a:lnSpc>
+              <a:defRPr sz="1200">
+                <a:solidFill>
+                  <a:srgbClr val="475569"/>
+                </a:solidFill>
+              </a:defRPr>
+            </a:pPr>
+            <a:r>
+              <a:t>工程師當面直言挑戰主管反映極致平等；崇尚先跑再修並由主管拍板，反映由上而下敏捷速決。</a:t>
+            </a:r>
+          </a:p>
+          <a:p>
+            <a:pPr>
+              <a:spcBef>
+                <a:spcPts val="900"/>
+              </a:spcBef>
+              <a:defRPr sz="1400" b="1">
+                <a:solidFill>
+                  <a:srgbClr val="0284C7"/>
                 </a:solidFill>
               </a:defRPr>
             </a:pPr>
@@ -5717,9 +5747,9 @@
           <a:p>
             <a:pPr>
               <a:lnSpc>
-                <a:spcPct val="135000"/>
+                <a:spcPct val="125000"/>
               </a:lnSpc>
-              <a:defRPr sz="1450">
+              <a:defRPr sz="1200">
                 <a:solidFill>
                   <a:srgbClr val="475569"/>
                 </a:solidFill>
@@ -5732,11 +5762,11 @@
           <a:p>
             <a:pPr>
               <a:spcBef>
-                <a:spcPts val="1600"/>
+                <a:spcPts val="900"/>
               </a:spcBef>
-              <a:defRPr sz="1700" b="1">
-                <a:solidFill>
-                  <a:srgbClr val="1E293B"/>
+              <a:defRPr sz="1400" b="1">
+                <a:solidFill>
+                  <a:srgbClr val="D97706"/>
                 </a:solidFill>
               </a:defRPr>
             </a:pPr>
@@ -5747,9 +5777,9 @@
           <a:p>
             <a:pPr>
               <a:lnSpc>
-                <a:spcPct val="135000"/>
+                <a:spcPct val="125000"/>
               </a:lnSpc>
-              <a:defRPr sz="1450">
+              <a:defRPr sz="1200">
                 <a:solidFill>
                   <a:srgbClr val="475569"/>
                 </a:solidFill>
@@ -5762,11 +5792,11 @@
           <a:p>
             <a:pPr>
               <a:spcBef>
-                <a:spcPts val="1600"/>
+                <a:spcPts val="900"/>
               </a:spcBef>
-              <a:defRPr sz="1700" b="1">
-                <a:solidFill>
-                  <a:srgbClr val="1E293B"/>
+              <a:defRPr sz="1400" b="1">
+                <a:solidFill>
+                  <a:srgbClr val="059669"/>
                 </a:solidFill>
               </a:defRPr>
             </a:pPr>
@@ -5777,9 +5807,9 @@
           <a:p>
             <a:pPr>
               <a:lnSpc>
-                <a:spcPct val="135000"/>
+                <a:spcPct val="125000"/>
               </a:lnSpc>
-              <a:defRPr sz="1450">
+              <a:defRPr sz="1200">
                 <a:solidFill>
                   <a:srgbClr val="475569"/>
                 </a:solidFill>
@@ -6864,11 +6894,11 @@
           </a:fontRef>
         </p:style>
         <p:txBody>
-          <a:bodyPr rtlCol="0" anchor="ctr" wrap="square" lIns="365760" rIns="365760" tIns="365760"/>
+          <a:bodyPr rtlCol="0" anchor="ctr" wrap="square" lIns="365760" rIns="365760" tIns="274320"/>
           <a:lstStyle/>
           <a:p>
             <a:pPr algn="ctr">
-              <a:defRPr sz="2000" b="1">
+              <a:defRPr sz="1800" b="1">
                 <a:solidFill>
                   <a:srgbClr val="1E293B"/>
                 </a:solidFill>
@@ -6881,9 +6911,9 @@
           <a:p>
             <a:pPr>
               <a:spcBef>
-                <a:spcPts val="400"/>
+                <a:spcPts val="300"/>
               </a:spcBef>
-              <a:defRPr sz="1500" b="1">
+              <a:defRPr sz="1350" b="1">
                 <a:solidFill>
                   <a:srgbClr val="0284C7"/>
                 </a:solidFill>
@@ -6896,11 +6926,41 @@
           <a:p>
             <a:pPr>
               <a:spcBef>
-                <a:spcPts val="1600"/>
+                <a:spcPts val="900"/>
               </a:spcBef>
-              <a:defRPr sz="1700" b="1">
-                <a:solidFill>
-                  <a:srgbClr val="1E293B"/>
+              <a:defRPr sz="1400" b="1">
+                <a:solidFill>
+                  <a:srgbClr val="4F46E5"/>
+                </a:solidFill>
+              </a:defRPr>
+            </a:pPr>
+            <a:r>
+              <a:t>題目線索：</a:t>
+            </a:r>
+          </a:p>
+          <a:p>
+            <a:pPr>
+              <a:lnSpc>
+                <a:spcPct val="125000"/>
+              </a:lnSpc>
+              <a:defRPr sz="1200">
+                <a:solidFill>
+                  <a:srgbClr val="475569"/>
+                </a:solidFill>
+              </a:defRPr>
+            </a:pPr>
+            <a:r>
+              <a:t>基層測試員平起平坐主導談判反映高度平等；堅持全員公開共審達成一致，反映神聖共識大承諾。</a:t>
+            </a:r>
+          </a:p>
+          <a:p>
+            <a:pPr>
+              <a:spcBef>
+                <a:spcPts val="900"/>
+              </a:spcBef>
+              <a:defRPr sz="1400" b="1">
+                <a:solidFill>
+                  <a:srgbClr val="0284C7"/>
                 </a:solidFill>
               </a:defRPr>
             </a:pPr>
@@ -6911,9 +6971,9 @@
           <a:p>
             <a:pPr>
               <a:lnSpc>
-                <a:spcPct val="135000"/>
+                <a:spcPct val="125000"/>
               </a:lnSpc>
-              <a:defRPr sz="1450">
+              <a:defRPr sz="1200">
                 <a:solidFill>
                   <a:srgbClr val="475569"/>
                 </a:solidFill>
@@ -6926,11 +6986,11 @@
           <a:p>
             <a:pPr>
               <a:spcBef>
-                <a:spcPts val="1600"/>
+                <a:spcPts val="900"/>
               </a:spcBef>
-              <a:defRPr sz="1700" b="1">
-                <a:solidFill>
-                  <a:srgbClr val="1E293B"/>
+              <a:defRPr sz="1400" b="1">
+                <a:solidFill>
+                  <a:srgbClr val="D97706"/>
                 </a:solidFill>
               </a:defRPr>
             </a:pPr>
@@ -6941,9 +7001,9 @@
           <a:p>
             <a:pPr>
               <a:lnSpc>
-                <a:spcPct val="135000"/>
+                <a:spcPct val="125000"/>
               </a:lnSpc>
-              <a:defRPr sz="1450">
+              <a:defRPr sz="1200">
                 <a:solidFill>
                   <a:srgbClr val="475569"/>
                 </a:solidFill>
@@ -6956,11 +7016,11 @@
           <a:p>
             <a:pPr>
               <a:spcBef>
-                <a:spcPts val="1600"/>
+                <a:spcPts val="900"/>
               </a:spcBef>
-              <a:defRPr sz="1700" b="1">
-                <a:solidFill>
-                  <a:srgbClr val="1E293B"/>
+              <a:defRPr sz="1400" b="1">
+                <a:solidFill>
+                  <a:srgbClr val="059669"/>
                 </a:solidFill>
               </a:defRPr>
             </a:pPr>
@@ -6971,9 +7031,9 @@
           <a:p>
             <a:pPr>
               <a:lnSpc>
-                <a:spcPct val="135000"/>
+                <a:spcPct val="125000"/>
               </a:lnSpc>
-              <a:defRPr sz="1450">
+              <a:defRPr sz="1200">
                 <a:solidFill>
                   <a:srgbClr val="475569"/>
                 </a:solidFill>
@@ -11502,11 +11562,11 @@
           </a:fontRef>
         </p:style>
         <p:txBody>
-          <a:bodyPr rtlCol="0" anchor="ctr" wrap="square" lIns="365760" rIns="365760" tIns="365760"/>
+          <a:bodyPr rtlCol="0" anchor="ctr" wrap="square" lIns="365760" rIns="365760" tIns="274320"/>
           <a:lstStyle/>
           <a:p>
             <a:pPr algn="ctr">
-              <a:defRPr sz="2000" b="1">
+              <a:defRPr sz="1800" b="1">
                 <a:solidFill>
                   <a:srgbClr val="1E293B"/>
                 </a:solidFill>
@@ -11519,9 +11579,9 @@
           <a:p>
             <a:pPr>
               <a:spcBef>
-                <a:spcPts val="400"/>
+                <a:spcPts val="300"/>
               </a:spcBef>
-              <a:defRPr sz="1500" b="1">
+              <a:defRPr sz="1350" b="1">
                 <a:solidFill>
                   <a:srgbClr val="0284C7"/>
                 </a:solidFill>
@@ -11534,11 +11594,41 @@
           <a:p>
             <a:pPr>
               <a:spcBef>
-                <a:spcPts val="1600"/>
+                <a:spcPts val="900"/>
               </a:spcBef>
-              <a:defRPr sz="1700" b="1">
-                <a:solidFill>
-                  <a:srgbClr val="1E293B"/>
+              <a:defRPr sz="1400" b="1">
+                <a:solidFill>
+                  <a:srgbClr val="4F46E5"/>
+                </a:solidFill>
+              </a:defRPr>
+            </a:pPr>
+            <a:r>
+              <a:t>題目線索：</a:t>
+            </a:r>
+          </a:p>
+          <a:p>
+            <a:pPr>
+              <a:lnSpc>
+                <a:spcPct val="125000"/>
+              </a:lnSpc>
+              <a:defRPr sz="1200">
+                <a:solidFill>
+                  <a:srgbClr val="475569"/>
+                </a:solidFill>
+              </a:defRPr>
+            </a:pPr>
+            <a:r>
+              <a:t>大會全員沉默低頭反映重階級；私下批評未在會前討論，則反映需事前摸底（根回）凝聚共識。</a:t>
+            </a:r>
+          </a:p>
+          <a:p>
+            <a:pPr>
+              <a:spcBef>
+                <a:spcPts val="900"/>
+              </a:spcBef>
+              <a:defRPr sz="1400" b="1">
+                <a:solidFill>
+                  <a:srgbClr val="0284C7"/>
                 </a:solidFill>
               </a:defRPr>
             </a:pPr>
@@ -11549,9 +11639,9 @@
           <a:p>
             <a:pPr>
               <a:lnSpc>
-                <a:spcPct val="135000"/>
+                <a:spcPct val="125000"/>
               </a:lnSpc>
-              <a:defRPr sz="1450">
+              <a:defRPr sz="1200">
                 <a:solidFill>
                   <a:srgbClr val="475569"/>
                 </a:solidFill>
@@ -11564,11 +11654,11 @@
           <a:p>
             <a:pPr>
               <a:spcBef>
-                <a:spcPts val="1600"/>
+                <a:spcPts val="900"/>
               </a:spcBef>
-              <a:defRPr sz="1700" b="1">
-                <a:solidFill>
-                  <a:srgbClr val="1E293B"/>
+              <a:defRPr sz="1400" b="1">
+                <a:solidFill>
+                  <a:srgbClr val="D97706"/>
                 </a:solidFill>
               </a:defRPr>
             </a:pPr>
@@ -11579,9 +11669,9 @@
           <a:p>
             <a:pPr>
               <a:lnSpc>
-                <a:spcPct val="135000"/>
+                <a:spcPct val="125000"/>
               </a:lnSpc>
-              <a:defRPr sz="1450">
+              <a:defRPr sz="1200">
                 <a:solidFill>
                   <a:srgbClr val="475569"/>
                 </a:solidFill>
@@ -11594,11 +11684,11 @@
           <a:p>
             <a:pPr>
               <a:spcBef>
-                <a:spcPts val="1600"/>
+                <a:spcPts val="900"/>
               </a:spcBef>
-              <a:defRPr sz="1700" b="1">
-                <a:solidFill>
-                  <a:srgbClr val="1E293B"/>
+              <a:defRPr sz="1400" b="1">
+                <a:solidFill>
+                  <a:srgbClr val="059669"/>
                 </a:solidFill>
               </a:defRPr>
             </a:pPr>
@@ -11609,9 +11699,9 @@
           <a:p>
             <a:pPr>
               <a:lnSpc>
-                <a:spcPct val="135000"/>
+                <a:spcPct val="125000"/>
               </a:lnSpc>
-              <a:defRPr sz="1450">
+              <a:defRPr sz="1200">
                 <a:solidFill>
                   <a:srgbClr val="475569"/>
                 </a:solidFill>
@@ -12696,11 +12786,11 @@
           </a:fontRef>
         </p:style>
         <p:txBody>
-          <a:bodyPr rtlCol="0" anchor="ctr" wrap="square" lIns="365760" rIns="365760" tIns="365760"/>
+          <a:bodyPr rtlCol="0" anchor="ctr" wrap="square" lIns="365760" rIns="365760" tIns="274320"/>
           <a:lstStyle/>
           <a:p>
             <a:pPr algn="ctr">
-              <a:defRPr sz="2000" b="1">
+              <a:defRPr sz="1800" b="1">
                 <a:solidFill>
                   <a:srgbClr val="1E293B"/>
                 </a:solidFill>
@@ -12713,9 +12803,9 @@
           <a:p>
             <a:pPr>
               <a:spcBef>
-                <a:spcPts val="400"/>
+                <a:spcPts val="300"/>
               </a:spcBef>
-              <a:defRPr sz="1500" b="1">
+              <a:defRPr sz="1350" b="1">
                 <a:solidFill>
                   <a:srgbClr val="0284C7"/>
                 </a:solidFill>
@@ -12728,11 +12818,41 @@
           <a:p>
             <a:pPr>
               <a:spcBef>
-                <a:spcPts val="1600"/>
+                <a:spcPts val="900"/>
               </a:spcBef>
-              <a:defRPr sz="1700" b="1">
-                <a:solidFill>
-                  <a:srgbClr val="1E293B"/>
+              <a:defRPr sz="1400" b="1">
+                <a:solidFill>
+                  <a:srgbClr val="4F46E5"/>
+                </a:solidFill>
+              </a:defRPr>
+            </a:pPr>
+            <a:r>
+              <a:t>題目線索：</a:t>
+            </a:r>
+          </a:p>
+          <a:p>
+            <a:pPr>
+              <a:lnSpc>
+                <a:spcPct val="125000"/>
+              </a:lnSpc>
+              <a:defRPr sz="1200">
+                <a:solidFill>
+                  <a:srgbClr val="475569"/>
+                </a:solidFill>
+              </a:defRPr>
+            </a:pPr>
+            <a:r>
+              <a:t>基層無人敢擅自做主反映重階層；領班急求主管明確裁示，反映危機時仰賴由上而下拍板擔責。</a:t>
+            </a:r>
+          </a:p>
+          <a:p>
+            <a:pPr>
+              <a:spcBef>
+                <a:spcPts val="900"/>
+              </a:spcBef>
+              <a:defRPr sz="1400" b="1">
+                <a:solidFill>
+                  <a:srgbClr val="0284C7"/>
                 </a:solidFill>
               </a:defRPr>
             </a:pPr>
@@ -12743,9 +12863,9 @@
           <a:p>
             <a:pPr>
               <a:lnSpc>
-                <a:spcPct val="135000"/>
+                <a:spcPct val="125000"/>
               </a:lnSpc>
-              <a:defRPr sz="1450">
+              <a:defRPr sz="1200">
                 <a:solidFill>
                   <a:srgbClr val="475569"/>
                 </a:solidFill>
@@ -12758,11 +12878,11 @@
           <a:p>
             <a:pPr>
               <a:spcBef>
-                <a:spcPts val="1600"/>
+                <a:spcPts val="900"/>
               </a:spcBef>
-              <a:defRPr sz="1700" b="1">
-                <a:solidFill>
-                  <a:srgbClr val="1E293B"/>
+              <a:defRPr sz="1400" b="1">
+                <a:solidFill>
+                  <a:srgbClr val="D97706"/>
                 </a:solidFill>
               </a:defRPr>
             </a:pPr>
@@ -12773,9 +12893,9 @@
           <a:p>
             <a:pPr>
               <a:lnSpc>
-                <a:spcPct val="135000"/>
+                <a:spcPct val="125000"/>
               </a:lnSpc>
-              <a:defRPr sz="1450">
+              <a:defRPr sz="1200">
                 <a:solidFill>
                   <a:srgbClr val="475569"/>
                 </a:solidFill>
@@ -12788,11 +12908,11 @@
           <a:p>
             <a:pPr>
               <a:spcBef>
-                <a:spcPts val="1600"/>
+                <a:spcPts val="900"/>
               </a:spcBef>
-              <a:defRPr sz="1700" b="1">
-                <a:solidFill>
-                  <a:srgbClr val="1E293B"/>
+              <a:defRPr sz="1400" b="1">
+                <a:solidFill>
+                  <a:srgbClr val="059669"/>
                 </a:solidFill>
               </a:defRPr>
             </a:pPr>
@@ -12803,9 +12923,9 @@
           <a:p>
             <a:pPr>
               <a:lnSpc>
-                <a:spcPct val="135000"/>
+                <a:spcPct val="125000"/>
               </a:lnSpc>
-              <a:defRPr sz="1450">
+              <a:defRPr sz="1200">
                 <a:solidFill>
                   <a:srgbClr val="475569"/>
                 </a:solidFill>

</xml_diff>

<commit_message>
style: enlarge scenario narration and dialogue font size on host view and slides
</commit_message>
<xml_diff>
--- a/誰是文化王_備案簡報_Who_Is_Culture_King.pptx
+++ b/誰是文化王_備案簡報_Who_Is_Culture_King.pptx
@@ -6063,7 +6063,7 @@
           <a:lstStyle/>
           <a:p>
             <a:pPr algn="ctr">
-              <a:defRPr sz="1300" b="1">
+              <a:defRPr sz="1400" b="1">
                 <a:solidFill>
                   <a:srgbClr val="0284C7"/>
                 </a:solidFill>
@@ -6078,7 +6078,7 @@
               <a:spcBef>
                 <a:spcPts val="600"/>
               </a:spcBef>
-              <a:defRPr sz="1100" b="1">
+              <a:defRPr sz="1300" b="1">
                 <a:solidFill>
                   <a:srgbClr val="1E293B"/>
                 </a:solidFill>
@@ -6091,9 +6091,9 @@
           <a:p>
             <a:pPr>
               <a:lnSpc>
-                <a:spcPct val="125000"/>
+                <a:spcPct val="120000"/>
               </a:lnSpc>
-              <a:defRPr sz="1050">
+              <a:defRPr sz="1200">
                 <a:solidFill>
                   <a:srgbClr val="475569"/>
                 </a:solidFill>
@@ -6108,7 +6108,7 @@
               <a:spcBef>
                 <a:spcPts val="600"/>
               </a:spcBef>
-              <a:defRPr sz="1100" b="1">
+              <a:defRPr sz="1300" b="1">
                 <a:solidFill>
                   <a:srgbClr val="1E293B"/>
                 </a:solidFill>
@@ -6121,9 +6121,9 @@
           <a:p>
             <a:pPr>
               <a:lnSpc>
-                <a:spcPct val="125000"/>
+                <a:spcPct val="120000"/>
               </a:lnSpc>
-              <a:defRPr sz="1050">
+              <a:defRPr sz="1200">
                 <a:solidFill>
                   <a:srgbClr val="475569"/>
                 </a:solidFill>
@@ -6138,7 +6138,7 @@
               <a:spcBef>
                 <a:spcPts val="600"/>
               </a:spcBef>
-              <a:defRPr sz="1100" b="1">
+              <a:defRPr sz="1300" b="1">
                 <a:solidFill>
                   <a:srgbClr val="1E293B"/>
                 </a:solidFill>
@@ -6151,9 +6151,9 @@
           <a:p>
             <a:pPr>
               <a:lnSpc>
-                <a:spcPct val="125000"/>
+                <a:spcPct val="120000"/>
               </a:lnSpc>
-              <a:defRPr sz="1050">
+              <a:defRPr sz="1200">
                 <a:solidFill>
                   <a:srgbClr val="475569"/>
                 </a:solidFill>
@@ -6168,7 +6168,7 @@
               <a:spcBef>
                 <a:spcPts val="600"/>
               </a:spcBef>
-              <a:defRPr sz="1100" b="1">
+              <a:defRPr sz="1300" b="1">
                 <a:solidFill>
                   <a:srgbClr val="1E293B"/>
                 </a:solidFill>
@@ -6181,9 +6181,9 @@
           <a:p>
             <a:pPr>
               <a:lnSpc>
-                <a:spcPct val="125000"/>
+                <a:spcPct val="120000"/>
               </a:lnSpc>
-              <a:defRPr sz="1050">
+              <a:defRPr sz="1200">
                 <a:solidFill>
                   <a:srgbClr val="475569"/>
                 </a:solidFill>
@@ -6235,7 +6235,7 @@
           <a:lstStyle/>
           <a:p>
             <a:pPr algn="ctr">
-              <a:defRPr sz="1200" b="1">
+              <a:defRPr sz="1350" b="1">
                 <a:solidFill>
                   <a:srgbClr val="FEF3C7"/>
                 </a:solidFill>
@@ -10731,7 +10731,7 @@
           <a:lstStyle/>
           <a:p>
             <a:pPr algn="ctr">
-              <a:defRPr sz="1300" b="1">
+              <a:defRPr sz="1400" b="1">
                 <a:solidFill>
                   <a:srgbClr val="0284C7"/>
                 </a:solidFill>
@@ -10746,7 +10746,7 @@
               <a:spcBef>
                 <a:spcPts val="600"/>
               </a:spcBef>
-              <a:defRPr sz="1100" b="1">
+              <a:defRPr sz="1300" b="1">
                 <a:solidFill>
                   <a:srgbClr val="1E293B"/>
                 </a:solidFill>
@@ -10759,9 +10759,9 @@
           <a:p>
             <a:pPr>
               <a:lnSpc>
-                <a:spcPct val="125000"/>
+                <a:spcPct val="120000"/>
               </a:lnSpc>
-              <a:defRPr sz="1050">
+              <a:defRPr sz="1200">
                 <a:solidFill>
                   <a:srgbClr val="475569"/>
                 </a:solidFill>
@@ -10776,7 +10776,7 @@
               <a:spcBef>
                 <a:spcPts val="600"/>
               </a:spcBef>
-              <a:defRPr sz="1100" b="1">
+              <a:defRPr sz="1300" b="1">
                 <a:solidFill>
                   <a:srgbClr val="1E293B"/>
                 </a:solidFill>
@@ -10789,9 +10789,9 @@
           <a:p>
             <a:pPr>
               <a:lnSpc>
-                <a:spcPct val="125000"/>
+                <a:spcPct val="120000"/>
               </a:lnSpc>
-              <a:defRPr sz="1050">
+              <a:defRPr sz="1200">
                 <a:solidFill>
                   <a:srgbClr val="475569"/>
                 </a:solidFill>
@@ -10806,7 +10806,7 @@
               <a:spcBef>
                 <a:spcPts val="600"/>
               </a:spcBef>
-              <a:defRPr sz="1100" b="1">
+              <a:defRPr sz="1300" b="1">
                 <a:solidFill>
                   <a:srgbClr val="1E293B"/>
                 </a:solidFill>
@@ -10819,9 +10819,9 @@
           <a:p>
             <a:pPr>
               <a:lnSpc>
-                <a:spcPct val="125000"/>
+                <a:spcPct val="120000"/>
               </a:lnSpc>
-              <a:defRPr sz="1050">
+              <a:defRPr sz="1200">
                 <a:solidFill>
                   <a:srgbClr val="475569"/>
                 </a:solidFill>
@@ -10836,7 +10836,7 @@
               <a:spcBef>
                 <a:spcPts val="600"/>
               </a:spcBef>
-              <a:defRPr sz="1100" b="1">
+              <a:defRPr sz="1300" b="1">
                 <a:solidFill>
                   <a:srgbClr val="1E293B"/>
                 </a:solidFill>
@@ -10849,9 +10849,9 @@
           <a:p>
             <a:pPr>
               <a:lnSpc>
-                <a:spcPct val="125000"/>
+                <a:spcPct val="120000"/>
               </a:lnSpc>
-              <a:defRPr sz="1050">
+              <a:defRPr sz="1200">
                 <a:solidFill>
                   <a:srgbClr val="475569"/>
                 </a:solidFill>
@@ -10903,7 +10903,7 @@
           <a:lstStyle/>
           <a:p>
             <a:pPr algn="ctr">
-              <a:defRPr sz="1200" b="1">
+              <a:defRPr sz="1350" b="1">
                 <a:solidFill>
                   <a:srgbClr val="FEF3C7"/>
                 </a:solidFill>
@@ -11955,7 +11955,7 @@
           <a:lstStyle/>
           <a:p>
             <a:pPr algn="ctr">
-              <a:defRPr sz="1300" b="1">
+              <a:defRPr sz="1400" b="1">
                 <a:solidFill>
                   <a:srgbClr val="0284C7"/>
                 </a:solidFill>
@@ -11970,7 +11970,7 @@
               <a:spcBef>
                 <a:spcPts val="600"/>
               </a:spcBef>
-              <a:defRPr sz="1100" b="1">
+              <a:defRPr sz="1300" b="1">
                 <a:solidFill>
                   <a:srgbClr val="1E293B"/>
                 </a:solidFill>
@@ -11983,9 +11983,9 @@
           <a:p>
             <a:pPr>
               <a:lnSpc>
-                <a:spcPct val="125000"/>
+                <a:spcPct val="120000"/>
               </a:lnSpc>
-              <a:defRPr sz="1050">
+              <a:defRPr sz="1200">
                 <a:solidFill>
                   <a:srgbClr val="475569"/>
                 </a:solidFill>
@@ -12000,7 +12000,7 @@
               <a:spcBef>
                 <a:spcPts val="600"/>
               </a:spcBef>
-              <a:defRPr sz="1100" b="1">
+              <a:defRPr sz="1300" b="1">
                 <a:solidFill>
                   <a:srgbClr val="1E293B"/>
                 </a:solidFill>
@@ -12013,9 +12013,9 @@
           <a:p>
             <a:pPr>
               <a:lnSpc>
-                <a:spcPct val="125000"/>
+                <a:spcPct val="120000"/>
               </a:lnSpc>
-              <a:defRPr sz="1050">
+              <a:defRPr sz="1200">
                 <a:solidFill>
                   <a:srgbClr val="475569"/>
                 </a:solidFill>
@@ -12030,7 +12030,7 @@
               <a:spcBef>
                 <a:spcPts val="600"/>
               </a:spcBef>
-              <a:defRPr sz="1100" b="1">
+              <a:defRPr sz="1300" b="1">
                 <a:solidFill>
                   <a:srgbClr val="1E293B"/>
                 </a:solidFill>
@@ -12043,9 +12043,9 @@
           <a:p>
             <a:pPr>
               <a:lnSpc>
-                <a:spcPct val="125000"/>
+                <a:spcPct val="120000"/>
               </a:lnSpc>
-              <a:defRPr sz="1050">
+              <a:defRPr sz="1200">
                 <a:solidFill>
                   <a:srgbClr val="475569"/>
                 </a:solidFill>
@@ -12060,7 +12060,7 @@
               <a:spcBef>
                 <a:spcPts val="600"/>
               </a:spcBef>
-              <a:defRPr sz="1100" b="1">
+              <a:defRPr sz="1300" b="1">
                 <a:solidFill>
                   <a:srgbClr val="1E293B"/>
                 </a:solidFill>
@@ -12073,9 +12073,9 @@
           <a:p>
             <a:pPr>
               <a:lnSpc>
-                <a:spcPct val="125000"/>
+                <a:spcPct val="120000"/>
               </a:lnSpc>
-              <a:defRPr sz="1050">
+              <a:defRPr sz="1200">
                 <a:solidFill>
                   <a:srgbClr val="475569"/>
                 </a:solidFill>
@@ -12127,7 +12127,7 @@
           <a:lstStyle/>
           <a:p>
             <a:pPr algn="ctr">
-              <a:defRPr sz="1200" b="1">
+              <a:defRPr sz="1350" b="1">
                 <a:solidFill>
                   <a:srgbClr val="FEF3C7"/>
                 </a:solidFill>
@@ -13179,7 +13179,7 @@
           <a:lstStyle/>
           <a:p>
             <a:pPr algn="ctr">
-              <a:defRPr sz="1300" b="1">
+              <a:defRPr sz="1400" b="1">
                 <a:solidFill>
                   <a:srgbClr val="0284C7"/>
                 </a:solidFill>
@@ -13194,7 +13194,7 @@
               <a:spcBef>
                 <a:spcPts val="600"/>
               </a:spcBef>
-              <a:defRPr sz="1100" b="1">
+              <a:defRPr sz="1300" b="1">
                 <a:solidFill>
                   <a:srgbClr val="1E293B"/>
                 </a:solidFill>
@@ -13207,9 +13207,9 @@
           <a:p>
             <a:pPr>
               <a:lnSpc>
-                <a:spcPct val="125000"/>
+                <a:spcPct val="120000"/>
               </a:lnSpc>
-              <a:defRPr sz="1050">
+              <a:defRPr sz="1200">
                 <a:solidFill>
                   <a:srgbClr val="475569"/>
                 </a:solidFill>
@@ -13224,7 +13224,7 @@
               <a:spcBef>
                 <a:spcPts val="600"/>
               </a:spcBef>
-              <a:defRPr sz="1100" b="1">
+              <a:defRPr sz="1300" b="1">
                 <a:solidFill>
                   <a:srgbClr val="1E293B"/>
                 </a:solidFill>
@@ -13237,9 +13237,9 @@
           <a:p>
             <a:pPr>
               <a:lnSpc>
-                <a:spcPct val="125000"/>
+                <a:spcPct val="120000"/>
               </a:lnSpc>
-              <a:defRPr sz="1050">
+              <a:defRPr sz="1200">
                 <a:solidFill>
                   <a:srgbClr val="475569"/>
                 </a:solidFill>
@@ -13254,7 +13254,7 @@
               <a:spcBef>
                 <a:spcPts val="600"/>
               </a:spcBef>
-              <a:defRPr sz="1100" b="1">
+              <a:defRPr sz="1300" b="1">
                 <a:solidFill>
                   <a:srgbClr val="1E293B"/>
                 </a:solidFill>
@@ -13267,9 +13267,9 @@
           <a:p>
             <a:pPr>
               <a:lnSpc>
-                <a:spcPct val="125000"/>
+                <a:spcPct val="120000"/>
               </a:lnSpc>
-              <a:defRPr sz="1050">
+              <a:defRPr sz="1200">
                 <a:solidFill>
                   <a:srgbClr val="475569"/>
                 </a:solidFill>
@@ -13284,7 +13284,7 @@
               <a:spcBef>
                 <a:spcPts val="600"/>
               </a:spcBef>
-              <a:defRPr sz="1100" b="1">
+              <a:defRPr sz="1300" b="1">
                 <a:solidFill>
                   <a:srgbClr val="1E293B"/>
                 </a:solidFill>
@@ -13297,9 +13297,9 @@
           <a:p>
             <a:pPr>
               <a:lnSpc>
-                <a:spcPct val="125000"/>
+                <a:spcPct val="120000"/>
               </a:lnSpc>
-              <a:defRPr sz="1050">
+              <a:defRPr sz="1200">
                 <a:solidFill>
                   <a:srgbClr val="475569"/>
                 </a:solidFill>
@@ -13351,7 +13351,7 @@
           <a:lstStyle/>
           <a:p>
             <a:pPr algn="ctr">
-              <a:defRPr sz="1200" b="1">
+              <a:defRPr sz="1350" b="1">
                 <a:solidFill>
                   <a:srgbClr val="FEF3C7"/>
                 </a:solidFill>

</xml_diff>

<commit_message>
style: further enlarge scenario dialogue, prompt, and mobile text size
</commit_message>
<xml_diff>
--- a/誰是文化王_備案簡報_Who_Is_Culture_King.pptx
+++ b/誰是文化王_備案簡報_Who_Is_Culture_King.pptx
@@ -6063,22 +6063,22 @@
           <a:lstStyle/>
           <a:p>
             <a:pPr algn="ctr">
+              <a:defRPr sz="1550" b="1">
+                <a:solidFill>
+                  <a:srgbClr val="0284C7"/>
+                </a:solidFill>
+              </a:defRPr>
+            </a:pPr>
+            <a:r>
+              <a:t>📍 全球首發 · 戰略客戶攤牌現場</a:t>
+            </a:r>
+          </a:p>
+          <a:p>
+            <a:pPr>
+              <a:spcBef>
+                <a:spcPts val="500"/>
+              </a:spcBef>
               <a:defRPr sz="1400" b="1">
-                <a:solidFill>
-                  <a:srgbClr val="0284C7"/>
-                </a:solidFill>
-              </a:defRPr>
-            </a:pPr>
-            <a:r>
-              <a:t>📍 全球首發 · 戰略客戶攤牌現場</a:t>
-            </a:r>
-          </a:p>
-          <a:p>
-            <a:pPr>
-              <a:spcBef>
-                <a:spcPts val="600"/>
-              </a:spcBef>
-              <a:defRPr sz="1300" b="1">
                 <a:solidFill>
                   <a:srgbClr val="1E293B"/>
                 </a:solidFill>
@@ -6093,7 +6093,7 @@
               <a:lnSpc>
                 <a:spcPct val="120000"/>
               </a:lnSpc>
-              <a:defRPr sz="1200">
+              <a:defRPr sz="1350">
                 <a:solidFill>
                   <a:srgbClr val="475569"/>
                 </a:solidFill>
@@ -6106,9 +6106,9 @@
           <a:p>
             <a:pPr>
               <a:spcBef>
-                <a:spcPts val="600"/>
+                <a:spcPts val="500"/>
               </a:spcBef>
-              <a:defRPr sz="1300" b="1">
+              <a:defRPr sz="1400" b="1">
                 <a:solidFill>
                   <a:srgbClr val="1E293B"/>
                 </a:solidFill>
@@ -6123,7 +6123,7 @@
               <a:lnSpc>
                 <a:spcPct val="120000"/>
               </a:lnSpc>
-              <a:defRPr sz="1200">
+              <a:defRPr sz="1350">
                 <a:solidFill>
                   <a:srgbClr val="475569"/>
                 </a:solidFill>
@@ -6136,9 +6136,9 @@
           <a:p>
             <a:pPr>
               <a:spcBef>
-                <a:spcPts val="600"/>
+                <a:spcPts val="500"/>
               </a:spcBef>
-              <a:defRPr sz="1300" b="1">
+              <a:defRPr sz="1400" b="1">
                 <a:solidFill>
                   <a:srgbClr val="1E293B"/>
                 </a:solidFill>
@@ -6153,7 +6153,7 @@
               <a:lnSpc>
                 <a:spcPct val="120000"/>
               </a:lnSpc>
-              <a:defRPr sz="1200">
+              <a:defRPr sz="1350">
                 <a:solidFill>
                   <a:srgbClr val="475569"/>
                 </a:solidFill>
@@ -6166,9 +6166,9 @@
           <a:p>
             <a:pPr>
               <a:spcBef>
-                <a:spcPts val="600"/>
+                <a:spcPts val="500"/>
               </a:spcBef>
-              <a:defRPr sz="1300" b="1">
+              <a:defRPr sz="1400" b="1">
                 <a:solidFill>
                   <a:srgbClr val="1E293B"/>
                 </a:solidFill>
@@ -6183,7 +6183,7 @@
               <a:lnSpc>
                 <a:spcPct val="120000"/>
               </a:lnSpc>
-              <a:defRPr sz="1200">
+              <a:defRPr sz="1350">
                 <a:solidFill>
                   <a:srgbClr val="475569"/>
                 </a:solidFill>
@@ -6203,8 +6203,8 @@
         </p:nvSpPr>
         <p:spPr>
           <a:xfrm>
-            <a:off x="5989320" y="5257800"/>
-            <a:ext cx="5468112" cy="1005840"/>
+            <a:off x="5989320" y="5212079"/>
+            <a:ext cx="5468112" cy="1051560"/>
           </a:xfrm>
           <a:prstGeom prst="roundRect">
             <a:avLst/>
@@ -6235,7 +6235,7 @@
           <a:lstStyle/>
           <a:p>
             <a:pPr algn="ctr">
-              <a:defRPr sz="1350" b="1">
+              <a:defRPr sz="1500" b="1">
                 <a:solidFill>
                   <a:srgbClr val="FEF3C7"/>
                 </a:solidFill>
@@ -10731,22 +10731,22 @@
           <a:lstStyle/>
           <a:p>
             <a:pPr algn="ctr">
+              <a:defRPr sz="1550" b="1">
+                <a:solidFill>
+                  <a:srgbClr val="0284C7"/>
+                </a:solidFill>
+              </a:defRPr>
+            </a:pPr>
+            <a:r>
+              <a:t>📍 海外併購 · 精密研發中心</a:t>
+            </a:r>
+          </a:p>
+          <a:p>
+            <a:pPr>
+              <a:spcBef>
+                <a:spcPts val="500"/>
+              </a:spcBef>
               <a:defRPr sz="1400" b="1">
-                <a:solidFill>
-                  <a:srgbClr val="0284C7"/>
-                </a:solidFill>
-              </a:defRPr>
-            </a:pPr>
-            <a:r>
-              <a:t>📍 海外併購 · 精密研發中心</a:t>
-            </a:r>
-          </a:p>
-          <a:p>
-            <a:pPr>
-              <a:spcBef>
-                <a:spcPts val="600"/>
-              </a:spcBef>
-              <a:defRPr sz="1300" b="1">
                 <a:solidFill>
                   <a:srgbClr val="1E293B"/>
                 </a:solidFill>
@@ -10761,7 +10761,7 @@
               <a:lnSpc>
                 <a:spcPct val="120000"/>
               </a:lnSpc>
-              <a:defRPr sz="1200">
+              <a:defRPr sz="1350">
                 <a:solidFill>
                   <a:srgbClr val="475569"/>
                 </a:solidFill>
@@ -10774,9 +10774,9 @@
           <a:p>
             <a:pPr>
               <a:spcBef>
-                <a:spcPts val="600"/>
+                <a:spcPts val="500"/>
               </a:spcBef>
-              <a:defRPr sz="1300" b="1">
+              <a:defRPr sz="1400" b="1">
                 <a:solidFill>
                   <a:srgbClr val="1E293B"/>
                 </a:solidFill>
@@ -10791,7 +10791,7 @@
               <a:lnSpc>
                 <a:spcPct val="120000"/>
               </a:lnSpc>
-              <a:defRPr sz="1200">
+              <a:defRPr sz="1350">
                 <a:solidFill>
                   <a:srgbClr val="475569"/>
                 </a:solidFill>
@@ -10804,9 +10804,9 @@
           <a:p>
             <a:pPr>
               <a:spcBef>
-                <a:spcPts val="600"/>
+                <a:spcPts val="500"/>
               </a:spcBef>
-              <a:defRPr sz="1300" b="1">
+              <a:defRPr sz="1400" b="1">
                 <a:solidFill>
                   <a:srgbClr val="1E293B"/>
                 </a:solidFill>
@@ -10821,7 +10821,7 @@
               <a:lnSpc>
                 <a:spcPct val="120000"/>
               </a:lnSpc>
-              <a:defRPr sz="1200">
+              <a:defRPr sz="1350">
                 <a:solidFill>
                   <a:srgbClr val="475569"/>
                 </a:solidFill>
@@ -10834,9 +10834,9 @@
           <a:p>
             <a:pPr>
               <a:spcBef>
-                <a:spcPts val="600"/>
+                <a:spcPts val="500"/>
               </a:spcBef>
-              <a:defRPr sz="1300" b="1">
+              <a:defRPr sz="1400" b="1">
                 <a:solidFill>
                   <a:srgbClr val="1E293B"/>
                 </a:solidFill>
@@ -10851,7 +10851,7 @@
               <a:lnSpc>
                 <a:spcPct val="120000"/>
               </a:lnSpc>
-              <a:defRPr sz="1200">
+              <a:defRPr sz="1350">
                 <a:solidFill>
                   <a:srgbClr val="475569"/>
                 </a:solidFill>
@@ -10871,8 +10871,8 @@
         </p:nvSpPr>
         <p:spPr>
           <a:xfrm>
-            <a:off x="5989320" y="5257800"/>
-            <a:ext cx="5468112" cy="1005840"/>
+            <a:off x="5989320" y="5212079"/>
+            <a:ext cx="5468112" cy="1051560"/>
           </a:xfrm>
           <a:prstGeom prst="roundRect">
             <a:avLst/>
@@ -10903,7 +10903,7 @@
           <a:lstStyle/>
           <a:p>
             <a:pPr algn="ctr">
-              <a:defRPr sz="1350" b="1">
+              <a:defRPr sz="1500" b="1">
                 <a:solidFill>
                   <a:srgbClr val="FEF3C7"/>
                 </a:solidFill>
@@ -11955,22 +11955,22 @@
           <a:lstStyle/>
           <a:p>
             <a:pPr algn="ctr">
+              <a:defRPr sz="1550" b="1">
+                <a:solidFill>
+                  <a:srgbClr val="0284C7"/>
+                </a:solidFill>
+              </a:defRPr>
+            </a:pPr>
+            <a:r>
+              <a:t>📍 海外量產 · 核心試產基地</a:t>
+            </a:r>
+          </a:p>
+          <a:p>
+            <a:pPr>
+              <a:spcBef>
+                <a:spcPts val="500"/>
+              </a:spcBef>
               <a:defRPr sz="1400" b="1">
-                <a:solidFill>
-                  <a:srgbClr val="0284C7"/>
-                </a:solidFill>
-              </a:defRPr>
-            </a:pPr>
-            <a:r>
-              <a:t>📍 海外量產 · 核心試產基地</a:t>
-            </a:r>
-          </a:p>
-          <a:p>
-            <a:pPr>
-              <a:spcBef>
-                <a:spcPts val="600"/>
-              </a:spcBef>
-              <a:defRPr sz="1300" b="1">
                 <a:solidFill>
                   <a:srgbClr val="1E293B"/>
                 </a:solidFill>
@@ -11985,7 +11985,7 @@
               <a:lnSpc>
                 <a:spcPct val="120000"/>
               </a:lnSpc>
-              <a:defRPr sz="1200">
+              <a:defRPr sz="1350">
                 <a:solidFill>
                   <a:srgbClr val="475569"/>
                 </a:solidFill>
@@ -11998,9 +11998,9 @@
           <a:p>
             <a:pPr>
               <a:spcBef>
-                <a:spcPts val="600"/>
+                <a:spcPts val="500"/>
               </a:spcBef>
-              <a:defRPr sz="1300" b="1">
+              <a:defRPr sz="1400" b="1">
                 <a:solidFill>
                   <a:srgbClr val="1E293B"/>
                 </a:solidFill>
@@ -12015,7 +12015,7 @@
               <a:lnSpc>
                 <a:spcPct val="120000"/>
               </a:lnSpc>
-              <a:defRPr sz="1200">
+              <a:defRPr sz="1350">
                 <a:solidFill>
                   <a:srgbClr val="475569"/>
                 </a:solidFill>
@@ -12028,9 +12028,9 @@
           <a:p>
             <a:pPr>
               <a:spcBef>
-                <a:spcPts val="600"/>
+                <a:spcPts val="500"/>
               </a:spcBef>
-              <a:defRPr sz="1300" b="1">
+              <a:defRPr sz="1400" b="1">
                 <a:solidFill>
                   <a:srgbClr val="1E293B"/>
                 </a:solidFill>
@@ -12045,7 +12045,7 @@
               <a:lnSpc>
                 <a:spcPct val="120000"/>
               </a:lnSpc>
-              <a:defRPr sz="1200">
+              <a:defRPr sz="1350">
                 <a:solidFill>
                   <a:srgbClr val="475569"/>
                 </a:solidFill>
@@ -12058,9 +12058,9 @@
           <a:p>
             <a:pPr>
               <a:spcBef>
-                <a:spcPts val="600"/>
+                <a:spcPts val="500"/>
               </a:spcBef>
-              <a:defRPr sz="1300" b="1">
+              <a:defRPr sz="1400" b="1">
                 <a:solidFill>
                   <a:srgbClr val="1E293B"/>
                 </a:solidFill>
@@ -12075,7 +12075,7 @@
               <a:lnSpc>
                 <a:spcPct val="120000"/>
               </a:lnSpc>
-              <a:defRPr sz="1200">
+              <a:defRPr sz="1350">
                 <a:solidFill>
                   <a:srgbClr val="475569"/>
                 </a:solidFill>
@@ -12095,8 +12095,8 @@
         </p:nvSpPr>
         <p:spPr>
           <a:xfrm>
-            <a:off x="5989320" y="5257800"/>
-            <a:ext cx="5468112" cy="1005840"/>
+            <a:off x="5989320" y="5212079"/>
+            <a:ext cx="5468112" cy="1051560"/>
           </a:xfrm>
           <a:prstGeom prst="roundRect">
             <a:avLst/>
@@ -12127,7 +12127,7 @@
           <a:lstStyle/>
           <a:p>
             <a:pPr algn="ctr">
-              <a:defRPr sz="1350" b="1">
+              <a:defRPr sz="1500" b="1">
                 <a:solidFill>
                   <a:srgbClr val="FEF3C7"/>
                 </a:solidFill>
@@ -13179,22 +13179,22 @@
           <a:lstStyle/>
           <a:p>
             <a:pPr algn="ctr">
+              <a:defRPr sz="1550" b="1">
+                <a:solidFill>
+                  <a:srgbClr val="0284C7"/>
+                </a:solidFill>
+              </a:defRPr>
+            </a:pPr>
+            <a:r>
+              <a:t>📍 新創研發 · 高速運算實驗室</a:t>
+            </a:r>
+          </a:p>
+          <a:p>
+            <a:pPr>
+              <a:spcBef>
+                <a:spcPts val="500"/>
+              </a:spcBef>
               <a:defRPr sz="1400" b="1">
-                <a:solidFill>
-                  <a:srgbClr val="0284C7"/>
-                </a:solidFill>
-              </a:defRPr>
-            </a:pPr>
-            <a:r>
-              <a:t>📍 新創研發 · 高速運算實驗室</a:t>
-            </a:r>
-          </a:p>
-          <a:p>
-            <a:pPr>
-              <a:spcBef>
-                <a:spcPts val="600"/>
-              </a:spcBef>
-              <a:defRPr sz="1300" b="1">
                 <a:solidFill>
                   <a:srgbClr val="1E293B"/>
                 </a:solidFill>
@@ -13209,7 +13209,7 @@
               <a:lnSpc>
                 <a:spcPct val="120000"/>
               </a:lnSpc>
-              <a:defRPr sz="1200">
+              <a:defRPr sz="1350">
                 <a:solidFill>
                   <a:srgbClr val="475569"/>
                 </a:solidFill>
@@ -13222,9 +13222,9 @@
           <a:p>
             <a:pPr>
               <a:spcBef>
-                <a:spcPts val="600"/>
+                <a:spcPts val="500"/>
               </a:spcBef>
-              <a:defRPr sz="1300" b="1">
+              <a:defRPr sz="1400" b="1">
                 <a:solidFill>
                   <a:srgbClr val="1E293B"/>
                 </a:solidFill>
@@ -13239,7 +13239,7 @@
               <a:lnSpc>
                 <a:spcPct val="120000"/>
               </a:lnSpc>
-              <a:defRPr sz="1200">
+              <a:defRPr sz="1350">
                 <a:solidFill>
                   <a:srgbClr val="475569"/>
                 </a:solidFill>
@@ -13252,9 +13252,9 @@
           <a:p>
             <a:pPr>
               <a:spcBef>
-                <a:spcPts val="600"/>
+                <a:spcPts val="500"/>
               </a:spcBef>
-              <a:defRPr sz="1300" b="1">
+              <a:defRPr sz="1400" b="1">
                 <a:solidFill>
                   <a:srgbClr val="1E293B"/>
                 </a:solidFill>
@@ -13269,7 +13269,7 @@
               <a:lnSpc>
                 <a:spcPct val="120000"/>
               </a:lnSpc>
-              <a:defRPr sz="1200">
+              <a:defRPr sz="1350">
                 <a:solidFill>
                   <a:srgbClr val="475569"/>
                 </a:solidFill>
@@ -13282,9 +13282,9 @@
           <a:p>
             <a:pPr>
               <a:spcBef>
-                <a:spcPts val="600"/>
+                <a:spcPts val="500"/>
               </a:spcBef>
-              <a:defRPr sz="1300" b="1">
+              <a:defRPr sz="1400" b="1">
                 <a:solidFill>
                   <a:srgbClr val="1E293B"/>
                 </a:solidFill>
@@ -13299,7 +13299,7 @@
               <a:lnSpc>
                 <a:spcPct val="120000"/>
               </a:lnSpc>
-              <a:defRPr sz="1200">
+              <a:defRPr sz="1350">
                 <a:solidFill>
                   <a:srgbClr val="475569"/>
                 </a:solidFill>
@@ -13319,8 +13319,8 @@
         </p:nvSpPr>
         <p:spPr>
           <a:xfrm>
-            <a:off x="5989320" y="5257800"/>
-            <a:ext cx="5468112" cy="1005840"/>
+            <a:off x="5989320" y="5212079"/>
+            <a:ext cx="5468112" cy="1051560"/>
           </a:xfrm>
           <a:prstGeom prst="roundRect">
             <a:avLst/>
@@ -13351,7 +13351,7 @@
           <a:lstStyle/>
           <a:p>
             <a:pPr algn="ctr">
-              <a:defRPr sz="1350" b="1">
+              <a:defRPr sz="1500" b="1">
                 <a:solidFill>
                   <a:srgbClr val="FEF3C7"/>
                 </a:solidFill>

</xml_diff>